<commit_message>
FINAL deck: politics row -> crypto
</commit_message>
<xml_diff>
--- a/slides/Kalshi_Knows_FINAL.pptx
+++ b/slides/Kalshi_Knows_FINAL.pptx
@@ -4074,175 +4074,39 @@
 </file>
 
 <file path=ppt/slides/slide10.xml><?xml version="1.0" encoding="utf-8"?>
-<p:sld xmlns:a="http://schemas.openxmlformats.org/drawingml/2006/main" xmlns:p="http://schemas.openxmlformats.org/presentationml/2006/main" xmlns:r="http://schemas.openxmlformats.org/officeDocument/2006/relationships">
+<p:sld xmlns:a="http://schemas.openxmlformats.org/drawingml/2006/main" xmlns:r="http://schemas.openxmlformats.org/officeDocument/2006/relationships" xmlns:mc="http://schemas.openxmlformats.org/markup-compatibility/2006" xmlns:mv="urn:schemas-microsoft-com:mac:vml" xmlns:p="http://schemas.openxmlformats.org/presentationml/2006/main" xmlns:c="http://schemas.openxmlformats.org/drawingml/2006/chart" xmlns:dgm="http://schemas.openxmlformats.org/drawingml/2006/diagram" xmlns:o="urn:schemas-microsoft-com:office:office" xmlns:v="urn:schemas-microsoft-com:vml" xmlns:pvml="urn:schemas-microsoft-com:office:powerpoint" xmlns:com="http://schemas.openxmlformats.org/drawingml/2006/compatibility" xmlns:p14="http://schemas.microsoft.com/office/powerpoint/2010/main" xmlns:p15="http://schemas.microsoft.com/office/powerpoint/2012/main" xmlns:ahyp="http://schemas.microsoft.com/office/drawing/2018/hyperlinkcolor">
   <p:cSld>
+    <p:bg>
+      <p:bgPr>
+        <a:solidFill>
+          <a:srgbClr val="0C0E10"/>
+        </a:solidFill>
+      </p:bgPr>
+    </p:bg>
     <p:spTree>
       <p:nvGrpSpPr>
-        <p:cNvPr id="1" name=""/>
+        <p:cNvPr id="224" name="Shape 224"/>
         <p:cNvGrpSpPr/>
         <p:nvPr/>
       </p:nvGrpSpPr>
-      <p:grpSpPr/>
-      <p:sp>
-        <p:nvSpPr>
-          <p:cNvPr id="16" name="Google Shape;16;p1"/>
-          <p:cNvSpPr/>
-          <p:nvPr/>
-        </p:nvSpPr>
-        <p:spPr>
-          <a:xfrm>
-            <a:off x="694944" y="612648"/>
-            <a:ext cx="9144000" cy="219456"/>
-          </a:xfrm>
-          <a:prstGeom prst="rect">
-            <a:avLst/>
-          </a:prstGeom>
-          <a:noFill/>
-          <a:ln>
-            <a:noFill/>
-          </a:ln>
-        </p:spPr>
-        <p:txBody>
-          <a:bodyPr anchorCtr="0" anchor="ctr" bIns="0" lIns="0" spcFirstLastPara="1" rIns="0" wrap="square" tIns="0">
-            <a:normAutofit/>
-          </a:bodyPr>
-          <a:lstStyle/>
-          <a:p>
-            <a:pPr indent="0" lvl="0" marL="0" marR="0" rtl="0" algn="l">
-              <a:spcBef>
-                <a:spcPts val="0"/>
-              </a:spcBef>
-              <a:spcAft>
-                <a:spcPts val="0"/>
-              </a:spcAft>
-              <a:buNone/>
-            </a:pPr>
-            <a:r>
-              <a:rPr b="0" i="0" lang="en-US" sz="1100" u="none" cap="none" strike="noStrike">
-                <a:solidFill>
-                  <a:srgbClr val="8B98A8"/>
-                </a:solidFill>
-                <a:latin typeface="Helvetica Neue"/>
-                <a:ea typeface="Helvetica Neue"/>
-                <a:cs typeface="Helvetica Neue"/>
-                <a:sym typeface="Helvetica Neue"/>
-              </a:rPr>
-              <a:t>PLAY THE VIDEO  ·  41 SECONDS</a:t>
-            </a:r>
-            <a:endParaRPr/>
-          </a:p>
-        </p:txBody>
-      </p:sp>
-      <p:sp>
-        <p:nvSpPr>
-          <p:cNvPr id="17" name="Google Shape;17;p1"/>
-          <p:cNvSpPr/>
-          <p:nvPr/>
-        </p:nvSpPr>
-        <p:spPr>
-          <a:xfrm>
-            <a:off x="685800" y="1581912"/>
-            <a:ext cx="9784080" cy="2468880"/>
-          </a:xfrm>
-          <a:prstGeom prst="rect">
-            <a:avLst/>
-          </a:prstGeom>
-          <a:noFill/>
-          <a:ln>
-            <a:noFill/>
-          </a:ln>
-        </p:spPr>
-        <p:txBody>
-          <a:bodyPr anchorCtr="0" anchor="ctr" bIns="0" lIns="0" spcFirstLastPara="1" rIns="0" wrap="square" tIns="0">
-            <a:normAutofit/>
-          </a:bodyPr>
-          <a:lstStyle/>
-          <a:p>
-            <a:pPr indent="0" lvl="0" marL="0" marR="0" rtl="0" algn="l">
-              <a:spcBef>
-                <a:spcPts val="0"/>
-              </a:spcBef>
-              <a:spcAft>
-                <a:spcPts val="0"/>
-              </a:spcAft>
-              <a:buClr>
-                <a:srgbClr val="F2F2EF"/>
-              </a:buClr>
-              <a:buSzPts val="5700"/>
-              <a:buFont typeface="Helvetica Neue"/>
-              <a:buNone/>
-            </a:pPr>
-            <a:r>
-              <a:rPr b="1" i="0" lang="en-US" sz="5700" u="none" cap="none" strike="noStrike">
-                <a:solidFill>
-                  <a:srgbClr val="F2F2EF"/>
-                </a:solidFill>
-                <a:latin typeface="Helvetica Neue"/>
-                <a:ea typeface="Helvetica Neue"/>
-                <a:cs typeface="Helvetica Neue"/>
-                <a:sym typeface="Helvetica Neue"/>
-              </a:rPr>
-              <a:t>▶  Kalshi Knows in 41 seconds</a:t>
-            </a:r>
-            <a:endParaRPr b="0" i="0" sz="6600" u="none" cap="none" strike="noStrike">
-              <a:solidFill>
-                <a:schemeClr val="dk1"/>
-              </a:solidFill>
-              <a:latin typeface="Inter"/>
-              <a:ea typeface="Inter"/>
-              <a:cs typeface="Inter"/>
-              <a:sym typeface="Inter"/>
-            </a:endParaRPr>
-          </a:p>
-          <a:p>
-            <a:pPr indent="0" lvl="0" marL="0" marR="0" rtl="0" algn="l">
-              <a:spcBef>
-                <a:spcPts val="0"/>
-              </a:spcBef>
-              <a:spcAft>
-                <a:spcPts val="0"/>
-              </a:spcAft>
-              <a:buClr>
-                <a:srgbClr val="F2F2EF"/>
-              </a:buClr>
-              <a:buSzPts val="5700"/>
-              <a:buFont typeface="Helvetica Neue"/>
-              <a:buNone/>
-            </a:pPr>
-            <a:r>
-              <a:rPr b="1" i="0" lang="en-US" sz="5700" u="none" cap="none" strike="noStrike">
-                <a:solidFill>
-                  <a:srgbClr val="F2F2EF"/>
-                </a:solidFill>
-                <a:latin typeface="Helvetica Neue"/>
-                <a:ea typeface="Helvetica Neue"/>
-                <a:cs typeface="Helvetica Neue"/>
-                <a:sym typeface="Helvetica Neue"/>
-              </a:rPr>
-              <a:t>first?</a:t>
-            </a:r>
-            <a:endParaRPr b="0" i="0" sz="6600" u="none" cap="none" strike="noStrike">
-              <a:solidFill>
-                <a:schemeClr val="dk1"/>
-              </a:solidFill>
-              <a:latin typeface="Inter"/>
-              <a:ea typeface="Inter"/>
-              <a:cs typeface="Inter"/>
-              <a:sym typeface="Inter"/>
-            </a:endParaRPr>
-          </a:p>
-        </p:txBody>
-      </p:sp>
-      <p:sp>
-        <p:nvSpPr>
-          <p:cNvPr id="18" name="Google Shape;18;p1"/>
-          <p:cNvSpPr/>
-          <p:nvPr/>
-        </p:nvSpPr>
-        <p:spPr>
-          <a:xfrm>
-            <a:off x="694944" y="4379976"/>
-            <a:ext cx="978408" cy="64008"/>
+      <p:grpSpPr>
+        <a:xfrm>
+          <a:off x="0" y="0"/>
+          <a:ext cx="0" cy="0"/>
+          <a:chOff x="0" y="0"/>
+          <a:chExt cx="0" cy="0"/>
+        </a:xfrm>
+      </p:grpSpPr>
+      <p:sp>
+        <p:nvSpPr>
+          <p:cNvPr id="225" name="Google Shape;225;p9"/>
+          <p:cNvSpPr/>
+          <p:nvPr/>
+        </p:nvSpPr>
+        <p:spPr>
+          <a:xfrm>
+            <a:off x="685800" y="347472"/>
+            <a:ext cx="329184" cy="50292"/>
           </a:xfrm>
           <a:prstGeom prst="rect">
             <a:avLst/>
@@ -4294,6 +4158,1752 @@
       </p:sp>
       <p:sp>
         <p:nvSpPr>
+          <p:cNvPr id="226" name="Google Shape;226;p9"/>
+          <p:cNvSpPr/>
+          <p:nvPr/>
+        </p:nvSpPr>
+        <p:spPr>
+          <a:xfrm>
+            <a:off x="685800" y="182880"/>
+            <a:ext cx="7772400" cy="164592"/>
+          </a:xfrm>
+          <a:prstGeom prst="rect">
+            <a:avLst/>
+          </a:prstGeom>
+          <a:noFill/>
+          <a:ln>
+            <a:noFill/>
+          </a:ln>
+        </p:spPr>
+        <p:txBody>
+          <a:bodyPr anchorCtr="0" anchor="ctr" bIns="0" lIns="0" spcFirstLastPara="1" rIns="0" wrap="square" tIns="0">
+            <a:normAutofit/>
+          </a:bodyPr>
+          <a:lstStyle/>
+          <a:p>
+            <a:pPr indent="0" lvl="0" marL="0" marR="0" rtl="0" algn="l">
+              <a:spcBef>
+                <a:spcPts val="0"/>
+              </a:spcBef>
+              <a:spcAft>
+                <a:spcPts val="0"/>
+              </a:spcAft>
+              <a:buClr>
+                <a:srgbClr val="8B98A8"/>
+              </a:buClr>
+              <a:buSzPts val="880"/>
+              <a:buFont typeface="Helvetica Neue"/>
+              <a:buNone/>
+            </a:pPr>
+            <a:r>
+              <a:rPr b="1" lang="en-US" sz="880">
+                <a:solidFill>
+                  <a:srgbClr val="8B98A8"/>
+                </a:solidFill>
+                <a:latin typeface="Helvetica Neue"/>
+                <a:ea typeface="Helvetica Neue"/>
+                <a:cs typeface="Helvetica Neue"/>
+                <a:sym typeface="Helvetica Neue"/>
+              </a:rPr>
+              <a:t>KALSHI KNOWS  /  NEXT</a:t>
+            </a:r>
+            <a:endParaRPr sz="880">
+              <a:solidFill>
+                <a:schemeClr val="dk1"/>
+              </a:solidFill>
+              <a:latin typeface="Inter"/>
+              <a:ea typeface="Inter"/>
+              <a:cs typeface="Inter"/>
+              <a:sym typeface="Inter"/>
+            </a:endParaRPr>
+          </a:p>
+        </p:txBody>
+      </p:sp>
+      <p:sp>
+        <p:nvSpPr>
+          <p:cNvPr id="227" name="Google Shape;227;p9"/>
+          <p:cNvSpPr/>
+          <p:nvPr/>
+        </p:nvSpPr>
+        <p:spPr>
+          <a:xfrm>
+            <a:off x="676656" y="649224"/>
+            <a:ext cx="10927080" cy="1143000"/>
+          </a:xfrm>
+          <a:prstGeom prst="rect">
+            <a:avLst/>
+          </a:prstGeom>
+          <a:noFill/>
+          <a:ln>
+            <a:noFill/>
+          </a:ln>
+        </p:spPr>
+        <p:txBody>
+          <a:bodyPr anchorCtr="0" anchor="t" bIns="0" lIns="4550" spcFirstLastPara="1" rIns="0" wrap="square" tIns="0">
+            <a:normAutofit/>
+          </a:bodyPr>
+          <a:lstStyle/>
+          <a:p>
+            <a:pPr indent="0" lvl="0" marL="0" marR="0" rtl="0" algn="l">
+              <a:spcBef>
+                <a:spcPts val="0"/>
+              </a:spcBef>
+              <a:spcAft>
+                <a:spcPts val="0"/>
+              </a:spcAft>
+              <a:buNone/>
+            </a:pPr>
+            <a:r>
+              <a:rPr lang="en-US" sz="3100">
+                <a:solidFill>
+                  <a:srgbClr val="F2F2EF"/>
+                </a:solidFill>
+                <a:latin typeface="Helvetica Neue"/>
+                <a:ea typeface="Helvetica Neue"/>
+                <a:cs typeface="Helvetica Neue"/>
+                <a:sym typeface="Helvetica Neue"/>
+              </a:rPr>
+              <a:t>Next: every market, a decade of data, RL on profit.</a:t>
+            </a:r>
+            <a:endParaRPr/>
+          </a:p>
+        </p:txBody>
+      </p:sp>
+      <p:sp>
+        <p:nvSpPr>
+          <p:cNvPr id="228" name="Google Shape;228;p9"/>
+          <p:cNvSpPr/>
+          <p:nvPr/>
+        </p:nvSpPr>
+        <p:spPr>
+          <a:xfrm>
+            <a:off x="704088" y="1627632"/>
+            <a:ext cx="10808208" cy="320040"/>
+          </a:xfrm>
+          <a:prstGeom prst="rect">
+            <a:avLst/>
+          </a:prstGeom>
+          <a:noFill/>
+          <a:ln>
+            <a:noFill/>
+          </a:ln>
+        </p:spPr>
+        <p:txBody>
+          <a:bodyPr anchorCtr="0" anchor="t" bIns="0" lIns="0" spcFirstLastPara="1" rIns="0" wrap="square" tIns="0">
+            <a:normAutofit/>
+          </a:bodyPr>
+          <a:lstStyle/>
+          <a:p>
+            <a:pPr indent="0" lvl="0" marL="0" marR="0" rtl="0" algn="l">
+              <a:spcBef>
+                <a:spcPts val="0"/>
+              </a:spcBef>
+              <a:spcAft>
+                <a:spcPts val="0"/>
+              </a:spcAft>
+              <a:buNone/>
+            </a:pPr>
+            <a:r>
+              <a:rPr lang="en-US" sz="1300">
+                <a:solidFill>
+                  <a:srgbClr val="8B98A8"/>
+                </a:solidFill>
+                <a:latin typeface="Helvetica Neue"/>
+                <a:ea typeface="Helvetica Neue"/>
+                <a:cs typeface="Helvetica Neue"/>
+                <a:sym typeface="Helvetica Neue"/>
+              </a:rPr>
+              <a:t>Train on 4.36M+ settled markets (Kalshi + Polymarket) with reinforcement learning; today we were limited by compute and training time</a:t>
+            </a:r>
+            <a:endParaRPr/>
+          </a:p>
+        </p:txBody>
+      </p:sp>
+      <p:cxnSp>
+        <p:nvCxnSpPr>
+          <p:cNvPr id="229" name="Google Shape;229;p9"/>
+          <p:cNvCxnSpPr/>
+          <p:nvPr/>
+        </p:nvCxnSpPr>
+        <p:spPr>
+          <a:xfrm>
+            <a:off x="640080" y="6373368"/>
+            <a:ext cx="10927080" cy="0"/>
+          </a:xfrm>
+          <a:prstGeom prst="straightConnector1">
+            <a:avLst/>
+          </a:prstGeom>
+          <a:noFill/>
+          <a:ln cap="flat" cmpd="sng" w="9525">
+            <a:solidFill>
+              <a:srgbClr val="32383E"/>
+            </a:solidFill>
+            <a:prstDash val="solid"/>
+            <a:round/>
+            <a:headEnd len="sm" w="sm" type="none"/>
+            <a:tailEnd len="sm" w="sm" type="none"/>
+          </a:ln>
+        </p:spPr>
+      </p:cxnSp>
+      <p:pic>
+        <p:nvPicPr>
+          <p:cNvPr descr="/mnt/data/kalshi_knows_rebuilt/assets/vss_mark_dark.png" id="230" name="Google Shape;230;p9"/>
+          <p:cNvPicPr preferRelativeResize="0"/>
+          <p:nvPr/>
+        </p:nvPicPr>
+        <p:blipFill rotWithShape="1">
+          <a:blip r:embed="rId3">
+            <a:alphaModFix/>
+          </a:blip>
+          <a:srcRect b="0" l="0" r="0" t="0"/>
+          <a:stretch/>
+        </p:blipFill>
+        <p:spPr>
+          <a:xfrm>
+            <a:off x="621792" y="6432804"/>
+            <a:ext cx="283464" cy="228600"/>
+          </a:xfrm>
+          <a:prstGeom prst="rect">
+            <a:avLst/>
+          </a:prstGeom>
+          <a:noFill/>
+          <a:ln>
+            <a:noFill/>
+          </a:ln>
+        </p:spPr>
+      </p:pic>
+      <p:sp>
+        <p:nvSpPr>
+          <p:cNvPr id="231" name="Google Shape;231;p9"/>
+          <p:cNvSpPr/>
+          <p:nvPr/>
+        </p:nvSpPr>
+        <p:spPr>
+          <a:xfrm>
+            <a:off x="1005840" y="6423660"/>
+            <a:ext cx="1600200" cy="182880"/>
+          </a:xfrm>
+          <a:prstGeom prst="rect">
+            <a:avLst/>
+          </a:prstGeom>
+          <a:noFill/>
+          <a:ln>
+            <a:noFill/>
+          </a:ln>
+        </p:spPr>
+        <p:txBody>
+          <a:bodyPr anchorCtr="0" anchor="ctr" bIns="0" lIns="0" spcFirstLastPara="1" rIns="0" wrap="square" tIns="0">
+            <a:normAutofit/>
+          </a:bodyPr>
+          <a:lstStyle/>
+          <a:p>
+            <a:pPr indent="0" lvl="0" marL="0" marR="0" rtl="0" algn="l">
+              <a:spcBef>
+                <a:spcPts val="0"/>
+              </a:spcBef>
+              <a:spcAft>
+                <a:spcPts val="0"/>
+              </a:spcAft>
+              <a:buClr>
+                <a:srgbClr val="8B98A8"/>
+              </a:buClr>
+              <a:buSzPts val="820"/>
+              <a:buFont typeface="Helvetica Neue"/>
+              <a:buNone/>
+            </a:pPr>
+            <a:r>
+              <a:rPr b="1" lang="en-US" sz="820">
+                <a:solidFill>
+                  <a:srgbClr val="8B98A8"/>
+                </a:solidFill>
+                <a:latin typeface="Helvetica Neue"/>
+                <a:ea typeface="Helvetica Neue"/>
+                <a:cs typeface="Helvetica Neue"/>
+                <a:sym typeface="Helvetica Neue"/>
+              </a:rPr>
+              <a:t>KALSHI KNOWS</a:t>
+            </a:r>
+            <a:endParaRPr sz="820">
+              <a:solidFill>
+                <a:schemeClr val="dk1"/>
+              </a:solidFill>
+              <a:latin typeface="Inter"/>
+              <a:ea typeface="Inter"/>
+              <a:cs typeface="Inter"/>
+              <a:sym typeface="Inter"/>
+            </a:endParaRPr>
+          </a:p>
+        </p:txBody>
+      </p:sp>
+      <p:sp>
+        <p:nvSpPr>
+          <p:cNvPr id="232" name="Google Shape;232;p9"/>
+          <p:cNvSpPr/>
+          <p:nvPr/>
+        </p:nvSpPr>
+        <p:spPr>
+          <a:xfrm>
+            <a:off x="3931920" y="6437376"/>
+            <a:ext cx="969264" cy="164592"/>
+          </a:xfrm>
+          <a:prstGeom prst="rect">
+            <a:avLst/>
+          </a:prstGeom>
+          <a:noFill/>
+          <a:ln>
+            <a:noFill/>
+          </a:ln>
+        </p:spPr>
+        <p:txBody>
+          <a:bodyPr anchorCtr="0" anchor="ctr" bIns="0" lIns="0" spcFirstLastPara="1" rIns="0" wrap="square" tIns="0">
+            <a:normAutofit/>
+          </a:bodyPr>
+          <a:lstStyle/>
+          <a:p>
+            <a:pPr indent="0" lvl="0" marL="0" marR="0" rtl="0" algn="ctr">
+              <a:spcBef>
+                <a:spcPts val="0"/>
+              </a:spcBef>
+              <a:spcAft>
+                <a:spcPts val="0"/>
+              </a:spcAft>
+              <a:buClr>
+                <a:srgbClr val="8B98A8"/>
+              </a:buClr>
+              <a:buSzPts val="780"/>
+              <a:buFont typeface="Helvetica Neue"/>
+              <a:buNone/>
+            </a:pPr>
+            <a:r>
+              <a:rPr lang="en-US" sz="780">
+                <a:solidFill>
+                  <a:srgbClr val="8B98A8"/>
+                </a:solidFill>
+                <a:latin typeface="Helvetica Neue"/>
+                <a:ea typeface="Helvetica Neue"/>
+                <a:cs typeface="Helvetica Neue"/>
+                <a:sym typeface="Helvetica Neue"/>
+              </a:rPr>
+              <a:t>QUESTION</a:t>
+            </a:r>
+            <a:endParaRPr sz="780">
+              <a:solidFill>
+                <a:schemeClr val="dk1"/>
+              </a:solidFill>
+              <a:latin typeface="Inter"/>
+              <a:ea typeface="Inter"/>
+              <a:cs typeface="Inter"/>
+              <a:sym typeface="Inter"/>
+            </a:endParaRPr>
+          </a:p>
+        </p:txBody>
+      </p:sp>
+      <p:sp>
+        <p:nvSpPr>
+          <p:cNvPr id="233" name="Google Shape;233;p9"/>
+          <p:cNvSpPr/>
+          <p:nvPr/>
+        </p:nvSpPr>
+        <p:spPr>
+          <a:xfrm>
+            <a:off x="4946904" y="6437376"/>
+            <a:ext cx="969264" cy="164592"/>
+          </a:xfrm>
+          <a:prstGeom prst="rect">
+            <a:avLst/>
+          </a:prstGeom>
+          <a:noFill/>
+          <a:ln>
+            <a:noFill/>
+          </a:ln>
+        </p:spPr>
+        <p:txBody>
+          <a:bodyPr anchorCtr="0" anchor="ctr" bIns="0" lIns="0" spcFirstLastPara="1" rIns="0" wrap="square" tIns="0">
+            <a:normAutofit/>
+          </a:bodyPr>
+          <a:lstStyle/>
+          <a:p>
+            <a:pPr indent="0" lvl="0" marL="0" marR="0" rtl="0" algn="ctr">
+              <a:spcBef>
+                <a:spcPts val="0"/>
+              </a:spcBef>
+              <a:spcAft>
+                <a:spcPts val="0"/>
+              </a:spcAft>
+              <a:buClr>
+                <a:srgbClr val="8B98A8"/>
+              </a:buClr>
+              <a:buSzPts val="780"/>
+              <a:buFont typeface="Helvetica Neue"/>
+              <a:buNone/>
+            </a:pPr>
+            <a:r>
+              <a:rPr lang="en-US" sz="780">
+                <a:solidFill>
+                  <a:srgbClr val="8B98A8"/>
+                </a:solidFill>
+                <a:latin typeface="Helvetica Neue"/>
+                <a:ea typeface="Helvetica Neue"/>
+                <a:cs typeface="Helvetica Neue"/>
+                <a:sym typeface="Helvetica Neue"/>
+              </a:rPr>
+              <a:t>PROTOTYPE</a:t>
+            </a:r>
+            <a:endParaRPr sz="780">
+              <a:solidFill>
+                <a:schemeClr val="dk1"/>
+              </a:solidFill>
+              <a:latin typeface="Inter"/>
+              <a:ea typeface="Inter"/>
+              <a:cs typeface="Inter"/>
+              <a:sym typeface="Inter"/>
+            </a:endParaRPr>
+          </a:p>
+        </p:txBody>
+      </p:sp>
+      <p:sp>
+        <p:nvSpPr>
+          <p:cNvPr id="234" name="Google Shape;234;p9"/>
+          <p:cNvSpPr/>
+          <p:nvPr/>
+        </p:nvSpPr>
+        <p:spPr>
+          <a:xfrm>
+            <a:off x="5961888" y="6437376"/>
+            <a:ext cx="969264" cy="164592"/>
+          </a:xfrm>
+          <a:prstGeom prst="rect">
+            <a:avLst/>
+          </a:prstGeom>
+          <a:noFill/>
+          <a:ln>
+            <a:noFill/>
+          </a:ln>
+        </p:spPr>
+        <p:txBody>
+          <a:bodyPr anchorCtr="0" anchor="ctr" bIns="0" lIns="0" spcFirstLastPara="1" rIns="0" wrap="square" tIns="0">
+            <a:normAutofit/>
+          </a:bodyPr>
+          <a:lstStyle/>
+          <a:p>
+            <a:pPr indent="0" lvl="0" marL="0" marR="0" rtl="0" algn="ctr">
+              <a:spcBef>
+                <a:spcPts val="0"/>
+              </a:spcBef>
+              <a:spcAft>
+                <a:spcPts val="0"/>
+              </a:spcAft>
+              <a:buClr>
+                <a:srgbClr val="8B98A8"/>
+              </a:buClr>
+              <a:buSzPts val="780"/>
+              <a:buFont typeface="Helvetica Neue"/>
+              <a:buNone/>
+            </a:pPr>
+            <a:r>
+              <a:rPr lang="en-US" sz="780">
+                <a:solidFill>
+                  <a:srgbClr val="8B98A8"/>
+                </a:solidFill>
+                <a:latin typeface="Helvetica Neue"/>
+                <a:ea typeface="Helvetica Neue"/>
+                <a:cs typeface="Helvetica Neue"/>
+                <a:sym typeface="Helvetica Neue"/>
+              </a:rPr>
+              <a:t>EVIDENCE</a:t>
+            </a:r>
+            <a:endParaRPr sz="780">
+              <a:solidFill>
+                <a:schemeClr val="dk1"/>
+              </a:solidFill>
+              <a:latin typeface="Inter"/>
+              <a:ea typeface="Inter"/>
+              <a:cs typeface="Inter"/>
+              <a:sym typeface="Inter"/>
+            </a:endParaRPr>
+          </a:p>
+        </p:txBody>
+      </p:sp>
+      <p:sp>
+        <p:nvSpPr>
+          <p:cNvPr id="235" name="Google Shape;235;p9"/>
+          <p:cNvSpPr/>
+          <p:nvPr/>
+        </p:nvSpPr>
+        <p:spPr>
+          <a:xfrm>
+            <a:off x="6976872" y="6437376"/>
+            <a:ext cx="969264" cy="164592"/>
+          </a:xfrm>
+          <a:prstGeom prst="rect">
+            <a:avLst/>
+          </a:prstGeom>
+          <a:noFill/>
+          <a:ln>
+            <a:noFill/>
+          </a:ln>
+        </p:spPr>
+        <p:txBody>
+          <a:bodyPr anchorCtr="0" anchor="ctr" bIns="0" lIns="0" spcFirstLastPara="1" rIns="0" wrap="square" tIns="0">
+            <a:normAutofit/>
+          </a:bodyPr>
+          <a:lstStyle/>
+          <a:p>
+            <a:pPr indent="0" lvl="0" marL="0" marR="0" rtl="0" algn="ctr">
+              <a:spcBef>
+                <a:spcPts val="0"/>
+              </a:spcBef>
+              <a:spcAft>
+                <a:spcPts val="0"/>
+              </a:spcAft>
+              <a:buClr>
+                <a:srgbClr val="8B98A8"/>
+              </a:buClr>
+              <a:buSzPts val="780"/>
+              <a:buFont typeface="Helvetica Neue"/>
+              <a:buNone/>
+            </a:pPr>
+            <a:r>
+              <a:rPr lang="en-US" sz="780">
+                <a:solidFill>
+                  <a:srgbClr val="8B98A8"/>
+                </a:solidFill>
+                <a:latin typeface="Helvetica Neue"/>
+                <a:ea typeface="Helvetica Neue"/>
+                <a:cs typeface="Helvetica Neue"/>
+                <a:sym typeface="Helvetica Neue"/>
+              </a:rPr>
+              <a:t>MARKET</a:t>
+            </a:r>
+            <a:endParaRPr sz="780">
+              <a:solidFill>
+                <a:schemeClr val="dk1"/>
+              </a:solidFill>
+              <a:latin typeface="Inter"/>
+              <a:ea typeface="Inter"/>
+              <a:cs typeface="Inter"/>
+              <a:sym typeface="Inter"/>
+            </a:endParaRPr>
+          </a:p>
+        </p:txBody>
+      </p:sp>
+      <p:sp>
+        <p:nvSpPr>
+          <p:cNvPr id="236" name="Google Shape;236;p9"/>
+          <p:cNvSpPr/>
+          <p:nvPr/>
+        </p:nvSpPr>
+        <p:spPr>
+          <a:xfrm>
+            <a:off x="7991856" y="6437376"/>
+            <a:ext cx="969264" cy="164592"/>
+          </a:xfrm>
+          <a:prstGeom prst="rect">
+            <a:avLst/>
+          </a:prstGeom>
+          <a:noFill/>
+          <a:ln>
+            <a:noFill/>
+          </a:ln>
+        </p:spPr>
+        <p:txBody>
+          <a:bodyPr anchorCtr="0" anchor="ctr" bIns="0" lIns="0" spcFirstLastPara="1" rIns="0" wrap="square" tIns="0">
+            <a:normAutofit/>
+          </a:bodyPr>
+          <a:lstStyle/>
+          <a:p>
+            <a:pPr indent="0" lvl="0" marL="0" marR="0" rtl="0" algn="ctr">
+              <a:spcBef>
+                <a:spcPts val="0"/>
+              </a:spcBef>
+              <a:spcAft>
+                <a:spcPts val="0"/>
+              </a:spcAft>
+              <a:buClr>
+                <a:srgbClr val="8B98A8"/>
+              </a:buClr>
+              <a:buSzPts val="780"/>
+              <a:buFont typeface="Helvetica Neue"/>
+              <a:buNone/>
+            </a:pPr>
+            <a:r>
+              <a:rPr lang="en-US" sz="780">
+                <a:solidFill>
+                  <a:srgbClr val="8B98A8"/>
+                </a:solidFill>
+                <a:latin typeface="Helvetica Neue"/>
+                <a:ea typeface="Helvetica Neue"/>
+                <a:cs typeface="Helvetica Neue"/>
+                <a:sym typeface="Helvetica Neue"/>
+              </a:rPr>
+              <a:t>EXPANSION</a:t>
+            </a:r>
+            <a:endParaRPr sz="780">
+              <a:solidFill>
+                <a:schemeClr val="dk1"/>
+              </a:solidFill>
+              <a:latin typeface="Inter"/>
+              <a:ea typeface="Inter"/>
+              <a:cs typeface="Inter"/>
+              <a:sym typeface="Inter"/>
+            </a:endParaRPr>
+          </a:p>
+        </p:txBody>
+      </p:sp>
+      <p:sp>
+        <p:nvSpPr>
+          <p:cNvPr id="237" name="Google Shape;237;p9"/>
+          <p:cNvSpPr/>
+          <p:nvPr/>
+        </p:nvSpPr>
+        <p:spPr>
+          <a:xfrm>
+            <a:off x="9006840" y="6437376"/>
+            <a:ext cx="969264" cy="164592"/>
+          </a:xfrm>
+          <a:prstGeom prst="rect">
+            <a:avLst/>
+          </a:prstGeom>
+          <a:noFill/>
+          <a:ln>
+            <a:noFill/>
+          </a:ln>
+        </p:spPr>
+        <p:txBody>
+          <a:bodyPr anchorCtr="0" anchor="ctr" bIns="0" lIns="0" spcFirstLastPara="1" rIns="0" wrap="square" tIns="0">
+            <a:normAutofit/>
+          </a:bodyPr>
+          <a:lstStyle/>
+          <a:p>
+            <a:pPr indent="0" lvl="0" marL="0" marR="0" rtl="0" algn="ctr">
+              <a:spcBef>
+                <a:spcPts val="0"/>
+              </a:spcBef>
+              <a:spcAft>
+                <a:spcPts val="0"/>
+              </a:spcAft>
+              <a:buClr>
+                <a:srgbClr val="8B98A8"/>
+              </a:buClr>
+              <a:buSzPts val="780"/>
+              <a:buFont typeface="Helvetica Neue"/>
+              <a:buNone/>
+            </a:pPr>
+            <a:r>
+              <a:rPr lang="en-US" sz="780">
+                <a:solidFill>
+                  <a:srgbClr val="8B98A8"/>
+                </a:solidFill>
+                <a:latin typeface="Helvetica Neue"/>
+                <a:ea typeface="Helvetica Neue"/>
+                <a:cs typeface="Helvetica Neue"/>
+                <a:sym typeface="Helvetica Neue"/>
+              </a:rPr>
+              <a:t>BUSINESS</a:t>
+            </a:r>
+            <a:endParaRPr sz="780">
+              <a:solidFill>
+                <a:schemeClr val="dk1"/>
+              </a:solidFill>
+              <a:latin typeface="Inter"/>
+              <a:ea typeface="Inter"/>
+              <a:cs typeface="Inter"/>
+              <a:sym typeface="Inter"/>
+            </a:endParaRPr>
+          </a:p>
+        </p:txBody>
+      </p:sp>
+      <p:sp>
+        <p:nvSpPr>
+          <p:cNvPr id="238" name="Google Shape;238;p9"/>
+          <p:cNvSpPr/>
+          <p:nvPr/>
+        </p:nvSpPr>
+        <p:spPr>
+          <a:xfrm>
+            <a:off x="10021824" y="6437376"/>
+            <a:ext cx="969264" cy="164592"/>
+          </a:xfrm>
+          <a:prstGeom prst="rect">
+            <a:avLst/>
+          </a:prstGeom>
+          <a:noFill/>
+          <a:ln>
+            <a:noFill/>
+          </a:ln>
+        </p:spPr>
+        <p:txBody>
+          <a:bodyPr anchorCtr="0" anchor="ctr" bIns="0" lIns="0" spcFirstLastPara="1" rIns="0" wrap="square" tIns="0">
+            <a:normAutofit/>
+          </a:bodyPr>
+          <a:lstStyle/>
+          <a:p>
+            <a:pPr indent="0" lvl="0" marL="0" marR="0" rtl="0" algn="ctr">
+              <a:spcBef>
+                <a:spcPts val="0"/>
+              </a:spcBef>
+              <a:spcAft>
+                <a:spcPts val="0"/>
+              </a:spcAft>
+              <a:buClr>
+                <a:srgbClr val="F2F2EF"/>
+              </a:buClr>
+              <a:buSzPts val="780"/>
+              <a:buFont typeface="Helvetica Neue"/>
+              <a:buNone/>
+            </a:pPr>
+            <a:r>
+              <a:rPr b="1" lang="en-US" sz="780">
+                <a:solidFill>
+                  <a:srgbClr val="F2F2EF"/>
+                </a:solidFill>
+                <a:latin typeface="Helvetica Neue"/>
+                <a:ea typeface="Helvetica Neue"/>
+                <a:cs typeface="Helvetica Neue"/>
+                <a:sym typeface="Helvetica Neue"/>
+              </a:rPr>
+              <a:t>NEXT</a:t>
+            </a:r>
+            <a:endParaRPr sz="780">
+              <a:solidFill>
+                <a:schemeClr val="dk1"/>
+              </a:solidFill>
+              <a:latin typeface="Inter"/>
+              <a:ea typeface="Inter"/>
+              <a:cs typeface="Inter"/>
+              <a:sym typeface="Inter"/>
+            </a:endParaRPr>
+          </a:p>
+        </p:txBody>
+      </p:sp>
+      <p:sp>
+        <p:nvSpPr>
+          <p:cNvPr id="239" name="Google Shape;239;p9"/>
+          <p:cNvSpPr/>
+          <p:nvPr/>
+        </p:nvSpPr>
+        <p:spPr>
+          <a:xfrm>
+            <a:off x="10021824" y="6364224"/>
+            <a:ext cx="960120" cy="22860"/>
+          </a:xfrm>
+          <a:prstGeom prst="rect">
+            <a:avLst/>
+          </a:prstGeom>
+          <a:solidFill>
+            <a:srgbClr val="F14C1B"/>
+          </a:solidFill>
+          <a:ln cap="flat" cmpd="sng" w="12700">
+            <a:solidFill>
+              <a:srgbClr val="F14C1B">
+                <a:alpha val="0"/>
+              </a:srgbClr>
+            </a:solidFill>
+            <a:prstDash val="solid"/>
+            <a:round/>
+            <a:headEnd len="sm" w="sm" type="none"/>
+            <a:tailEnd len="sm" w="sm" type="none"/>
+          </a:ln>
+        </p:spPr>
+        <p:txBody>
+          <a:bodyPr anchorCtr="0" anchor="t" bIns="45700" lIns="91425" spcFirstLastPara="1" rIns="91425" wrap="square" tIns="45700">
+            <a:noAutofit/>
+          </a:bodyPr>
+          <a:lstStyle/>
+          <a:p>
+            <a:pPr indent="0" lvl="0" marL="0" marR="0" rtl="0" algn="l">
+              <a:spcBef>
+                <a:spcPts val="0"/>
+              </a:spcBef>
+              <a:spcAft>
+                <a:spcPts val="0"/>
+              </a:spcAft>
+              <a:buNone/>
+            </a:pPr>
+            <a:r>
+              <a:t/>
+            </a:r>
+            <a:endParaRPr sz="1800">
+              <a:solidFill>
+                <a:schemeClr val="dk1"/>
+              </a:solidFill>
+              <a:latin typeface="Inter"/>
+              <a:ea typeface="Inter"/>
+              <a:cs typeface="Inter"/>
+              <a:sym typeface="Inter"/>
+            </a:endParaRPr>
+          </a:p>
+        </p:txBody>
+      </p:sp>
+      <p:sp>
+        <p:nvSpPr>
+          <p:cNvPr id="240" name="Google Shape;240;p9"/>
+          <p:cNvSpPr/>
+          <p:nvPr/>
+        </p:nvSpPr>
+        <p:spPr>
+          <a:xfrm>
+            <a:off x="11320272" y="6423660"/>
+            <a:ext cx="210312" cy="201168"/>
+          </a:xfrm>
+          <a:prstGeom prst="rect">
+            <a:avLst/>
+          </a:prstGeom>
+          <a:noFill/>
+          <a:ln>
+            <a:noFill/>
+          </a:ln>
+        </p:spPr>
+        <p:txBody>
+          <a:bodyPr anchorCtr="0" anchor="ctr" bIns="0" lIns="0" spcFirstLastPara="1" rIns="0" wrap="square" tIns="0">
+            <a:normAutofit/>
+          </a:bodyPr>
+          <a:lstStyle/>
+          <a:p>
+            <a:pPr indent="0" lvl="0" marL="0" marR="0" rtl="0" algn="l">
+              <a:spcBef>
+                <a:spcPts val="0"/>
+              </a:spcBef>
+              <a:spcAft>
+                <a:spcPts val="0"/>
+              </a:spcAft>
+              <a:buNone/>
+            </a:pPr>
+            <a:r>
+              <a:rPr lang="en-US" sz="850">
+                <a:solidFill>
+                  <a:schemeClr val="dk1"/>
+                </a:solidFill>
+                <a:latin typeface="Helvetica Neue"/>
+                <a:ea typeface="Helvetica Neue"/>
+                <a:cs typeface="Helvetica Neue"/>
+                <a:sym typeface="Helvetica Neue"/>
+              </a:rPr>
+              <a:t>10</a:t>
+            </a:r>
+            <a:endParaRPr/>
+          </a:p>
+        </p:txBody>
+      </p:sp>
+      <p:sp>
+        <p:nvSpPr>
+          <p:cNvPr id="241" name="Google Shape;241;p9"/>
+          <p:cNvSpPr/>
+          <p:nvPr/>
+        </p:nvSpPr>
+        <p:spPr>
+          <a:xfrm>
+            <a:off x="704088" y="6153912"/>
+            <a:ext cx="10826496" cy="164592"/>
+          </a:xfrm>
+          <a:prstGeom prst="rect">
+            <a:avLst/>
+          </a:prstGeom>
+          <a:noFill/>
+          <a:ln>
+            <a:noFill/>
+          </a:ln>
+        </p:spPr>
+        <p:txBody>
+          <a:bodyPr anchorCtr="0" anchor="ctr" bIns="0" lIns="0" spcFirstLastPara="1" rIns="0" wrap="square" tIns="0">
+            <a:normAutofit/>
+          </a:bodyPr>
+          <a:lstStyle/>
+          <a:p>
+            <a:pPr indent="0" lvl="0" marL="0" marR="0" rtl="0" algn="l">
+              <a:spcBef>
+                <a:spcPts val="0"/>
+              </a:spcBef>
+              <a:spcAft>
+                <a:spcPts val="0"/>
+              </a:spcAft>
+              <a:buClr>
+                <a:srgbClr val="8B98A8"/>
+              </a:buClr>
+              <a:buSzPts val="810"/>
+              <a:buFont typeface="Helvetica Neue"/>
+              <a:buNone/>
+            </a:pPr>
+            <a:r>
+              <a:rPr lang="en-US" sz="810">
+                <a:solidFill>
+                  <a:srgbClr val="8B98A8"/>
+                </a:solidFill>
+                <a:latin typeface="Helvetica Neue"/>
+                <a:ea typeface="Helvetica Neue"/>
+                <a:cs typeface="Helvetica Neue"/>
+                <a:sym typeface="Helvetica Neue"/>
+              </a:rPr>
+              <a:t>Targets, not results · Public data only · No real money · Not betting advice · 21+ · Gambling problem? 1-800-GAMBLER</a:t>
+            </a:r>
+            <a:endParaRPr sz="715">
+              <a:solidFill>
+                <a:schemeClr val="dk1"/>
+              </a:solidFill>
+              <a:latin typeface="Inter"/>
+              <a:ea typeface="Inter"/>
+              <a:cs typeface="Inter"/>
+              <a:sym typeface="Inter"/>
+            </a:endParaRPr>
+          </a:p>
+        </p:txBody>
+      </p:sp>
+      <p:sp>
+        <p:nvSpPr>
+          <p:cNvPr id="242" name="Google Shape;242;p9"/>
+          <p:cNvSpPr/>
+          <p:nvPr/>
+        </p:nvSpPr>
+        <p:spPr>
+          <a:xfrm>
+            <a:off x="786384" y="2459736"/>
+            <a:ext cx="3337560" cy="64008"/>
+          </a:xfrm>
+          <a:prstGeom prst="rect">
+            <a:avLst/>
+          </a:prstGeom>
+          <a:solidFill>
+            <a:srgbClr val="F14C1B"/>
+          </a:solidFill>
+          <a:ln cap="flat" cmpd="sng" w="12700">
+            <a:solidFill>
+              <a:srgbClr val="F14C1B">
+                <a:alpha val="0"/>
+              </a:srgbClr>
+            </a:solidFill>
+            <a:prstDash val="solid"/>
+            <a:round/>
+            <a:headEnd len="sm" w="sm" type="none"/>
+            <a:tailEnd len="sm" w="sm" type="none"/>
+          </a:ln>
+        </p:spPr>
+        <p:txBody>
+          <a:bodyPr anchorCtr="0" anchor="t" bIns="45700" lIns="91425" spcFirstLastPara="1" rIns="91425" wrap="square" tIns="45700">
+            <a:noAutofit/>
+          </a:bodyPr>
+          <a:lstStyle/>
+          <a:p>
+            <a:pPr indent="0" lvl="0" marL="0" marR="0" rtl="0" algn="l">
+              <a:spcBef>
+                <a:spcPts val="0"/>
+              </a:spcBef>
+              <a:spcAft>
+                <a:spcPts val="0"/>
+              </a:spcAft>
+              <a:buNone/>
+            </a:pPr>
+            <a:r>
+              <a:t/>
+            </a:r>
+            <a:endParaRPr sz="1800">
+              <a:solidFill>
+                <a:schemeClr val="dk1"/>
+              </a:solidFill>
+              <a:latin typeface="Inter"/>
+              <a:ea typeface="Inter"/>
+              <a:cs typeface="Inter"/>
+              <a:sym typeface="Inter"/>
+            </a:endParaRPr>
+          </a:p>
+        </p:txBody>
+      </p:sp>
+      <p:sp>
+        <p:nvSpPr>
+          <p:cNvPr id="243" name="Google Shape;243;p9"/>
+          <p:cNvSpPr/>
+          <p:nvPr/>
+        </p:nvSpPr>
+        <p:spPr>
+          <a:xfrm>
+            <a:off x="786384" y="2697480"/>
+            <a:ext cx="3236976" cy="274320"/>
+          </a:xfrm>
+          <a:prstGeom prst="rect">
+            <a:avLst/>
+          </a:prstGeom>
+          <a:noFill/>
+          <a:ln>
+            <a:noFill/>
+          </a:ln>
+        </p:spPr>
+        <p:txBody>
+          <a:bodyPr anchorCtr="0" anchor="ctr" bIns="0" lIns="0" spcFirstLastPara="1" rIns="0" wrap="square" tIns="0">
+            <a:normAutofit/>
+          </a:bodyPr>
+          <a:lstStyle/>
+          <a:p>
+            <a:pPr indent="0" lvl="0" marL="0" marR="0" rtl="0" algn="l">
+              <a:spcBef>
+                <a:spcPts val="0"/>
+              </a:spcBef>
+              <a:spcAft>
+                <a:spcPts val="0"/>
+              </a:spcAft>
+              <a:buNone/>
+            </a:pPr>
+            <a:r>
+              <a:rPr lang="en-US" sz="1000">
+                <a:solidFill>
+                  <a:srgbClr val="F14C1B"/>
+                </a:solidFill>
+                <a:latin typeface="Helvetica Neue"/>
+                <a:ea typeface="Helvetica Neue"/>
+                <a:cs typeface="Helvetica Neue"/>
+                <a:sym typeface="Helvetica Neue"/>
+              </a:rPr>
+              <a:t>NEXT  /  2 WEEKS</a:t>
+            </a:r>
+            <a:endParaRPr/>
+          </a:p>
+        </p:txBody>
+      </p:sp>
+      <p:sp>
+        <p:nvSpPr>
+          <p:cNvPr id="244" name="Google Shape;244;p9"/>
+          <p:cNvSpPr/>
+          <p:nvPr/>
+        </p:nvSpPr>
+        <p:spPr>
+          <a:xfrm>
+            <a:off x="786384" y="3209544"/>
+            <a:ext cx="3255264" cy="905256"/>
+          </a:xfrm>
+          <a:prstGeom prst="rect">
+            <a:avLst/>
+          </a:prstGeom>
+          <a:noFill/>
+          <a:ln>
+            <a:noFill/>
+          </a:ln>
+        </p:spPr>
+        <p:txBody>
+          <a:bodyPr anchorCtr="0" anchor="t" bIns="0" lIns="0" spcFirstLastPara="1" rIns="0" wrap="square" tIns="0">
+            <a:normAutofit/>
+          </a:bodyPr>
+          <a:lstStyle/>
+          <a:p>
+            <a:pPr indent="0" lvl="0" marL="0" marR="0" rtl="0" algn="l">
+              <a:spcBef>
+                <a:spcPts val="0"/>
+              </a:spcBef>
+              <a:spcAft>
+                <a:spcPts val="0"/>
+              </a:spcAft>
+              <a:buNone/>
+            </a:pPr>
+            <a:r>
+              <a:rPr lang="en-US" sz="1900">
+                <a:solidFill>
+                  <a:srgbClr val="F2F2EF"/>
+                </a:solidFill>
+                <a:latin typeface="Helvetica Neue"/>
+                <a:ea typeface="Helvetica Neue"/>
+                <a:cs typeface="Helvetica Neue"/>
+                <a:sym typeface="Helvetica Neue"/>
+              </a:rPr>
+              <a:t>Test on new games</a:t>
+            </a:r>
+            <a:endParaRPr/>
+          </a:p>
+        </p:txBody>
+      </p:sp>
+      <p:sp>
+        <p:nvSpPr>
+          <p:cNvPr id="245" name="Google Shape;245;p9"/>
+          <p:cNvSpPr/>
+          <p:nvPr/>
+        </p:nvSpPr>
+        <p:spPr>
+          <a:xfrm>
+            <a:off x="786384" y="4361688"/>
+            <a:ext cx="3200400" cy="1207008"/>
+          </a:xfrm>
+          <a:prstGeom prst="rect">
+            <a:avLst/>
+          </a:prstGeom>
+          <a:noFill/>
+          <a:ln>
+            <a:noFill/>
+          </a:ln>
+        </p:spPr>
+        <p:txBody>
+          <a:bodyPr anchorCtr="0" anchor="t" bIns="0" lIns="0" spcFirstLastPara="1" rIns="0" wrap="square" tIns="0">
+            <a:normAutofit/>
+          </a:bodyPr>
+          <a:lstStyle/>
+          <a:p>
+            <a:pPr indent="0" lvl="0" marL="0" marR="0" rtl="0" algn="l">
+              <a:spcBef>
+                <a:spcPts val="0"/>
+              </a:spcBef>
+              <a:spcAft>
+                <a:spcPts val="0"/>
+              </a:spcAft>
+              <a:buNone/>
+            </a:pPr>
+            <a:r>
+              <a:rPr lang="en-US" sz="1200">
+                <a:solidFill>
+                  <a:srgbClr val="8B98A8"/>
+                </a:solidFill>
+                <a:latin typeface="Helvetica Neue"/>
+                <a:ea typeface="Helvetica Neue"/>
+                <a:cs typeface="Helvetica Neue"/>
+                <a:sym typeface="Helvetica Neue"/>
+              </a:rPr>
+              <a:t>Record every alert, check the timing and count false alarms</a:t>
+            </a:r>
+            <a:endParaRPr/>
+          </a:p>
+        </p:txBody>
+      </p:sp>
+      <p:sp>
+        <p:nvSpPr>
+          <p:cNvPr id="246" name="Google Shape;246;p9"/>
+          <p:cNvSpPr/>
+          <p:nvPr/>
+        </p:nvSpPr>
+        <p:spPr>
+          <a:xfrm>
+            <a:off x="4498848" y="2459736"/>
+            <a:ext cx="3337560" cy="64008"/>
+          </a:xfrm>
+          <a:prstGeom prst="rect">
+            <a:avLst/>
+          </a:prstGeom>
+          <a:solidFill>
+            <a:srgbClr val="F14C1B"/>
+          </a:solidFill>
+          <a:ln cap="flat" cmpd="sng" w="12700">
+            <a:solidFill>
+              <a:srgbClr val="F14C1B">
+                <a:alpha val="0"/>
+              </a:srgbClr>
+            </a:solidFill>
+            <a:prstDash val="solid"/>
+            <a:round/>
+            <a:headEnd len="sm" w="sm" type="none"/>
+            <a:tailEnd len="sm" w="sm" type="none"/>
+          </a:ln>
+        </p:spPr>
+        <p:txBody>
+          <a:bodyPr anchorCtr="0" anchor="t" bIns="45700" lIns="91425" spcFirstLastPara="1" rIns="91425" wrap="square" tIns="45700">
+            <a:noAutofit/>
+          </a:bodyPr>
+          <a:lstStyle/>
+          <a:p>
+            <a:pPr indent="0" lvl="0" marL="0" marR="0" rtl="0" algn="l">
+              <a:spcBef>
+                <a:spcPts val="0"/>
+              </a:spcBef>
+              <a:spcAft>
+                <a:spcPts val="0"/>
+              </a:spcAft>
+              <a:buNone/>
+            </a:pPr>
+            <a:r>
+              <a:t/>
+            </a:r>
+            <a:endParaRPr sz="1800">
+              <a:solidFill>
+                <a:schemeClr val="dk1"/>
+              </a:solidFill>
+              <a:latin typeface="Inter"/>
+              <a:ea typeface="Inter"/>
+              <a:cs typeface="Inter"/>
+              <a:sym typeface="Inter"/>
+            </a:endParaRPr>
+          </a:p>
+        </p:txBody>
+      </p:sp>
+      <p:sp>
+        <p:nvSpPr>
+          <p:cNvPr id="247" name="Google Shape;247;p9"/>
+          <p:cNvSpPr/>
+          <p:nvPr/>
+        </p:nvSpPr>
+        <p:spPr>
+          <a:xfrm>
+            <a:off x="4498848" y="2697480"/>
+            <a:ext cx="3236976" cy="274320"/>
+          </a:xfrm>
+          <a:prstGeom prst="rect">
+            <a:avLst/>
+          </a:prstGeom>
+          <a:noFill/>
+          <a:ln>
+            <a:noFill/>
+          </a:ln>
+        </p:spPr>
+        <p:txBody>
+          <a:bodyPr anchorCtr="0" anchor="ctr" bIns="0" lIns="0" spcFirstLastPara="1" rIns="0" wrap="square" tIns="0">
+            <a:normAutofit/>
+          </a:bodyPr>
+          <a:lstStyle/>
+          <a:p>
+            <a:pPr indent="0" lvl="0" marL="0" marR="0" rtl="0" algn="l">
+              <a:spcBef>
+                <a:spcPts val="0"/>
+              </a:spcBef>
+              <a:spcAft>
+                <a:spcPts val="0"/>
+              </a:spcAft>
+              <a:buNone/>
+            </a:pPr>
+            <a:r>
+              <a:rPr lang="en-US" sz="1000">
+                <a:solidFill>
+                  <a:srgbClr val="F14C1B"/>
+                </a:solidFill>
+                <a:latin typeface="Helvetica Neue"/>
+                <a:ea typeface="Helvetica Neue"/>
+                <a:cs typeface="Helvetica Neue"/>
+                <a:sym typeface="Helvetica Neue"/>
+              </a:rPr>
+              <a:t>AFTER THAT  /  1–3 MONTHS</a:t>
+            </a:r>
+            <a:endParaRPr/>
+          </a:p>
+        </p:txBody>
+      </p:sp>
+      <p:sp>
+        <p:nvSpPr>
+          <p:cNvPr id="248" name="Google Shape;248;p9"/>
+          <p:cNvSpPr/>
+          <p:nvPr/>
+        </p:nvSpPr>
+        <p:spPr>
+          <a:xfrm>
+            <a:off x="4498848" y="3209544"/>
+            <a:ext cx="3255264" cy="905256"/>
+          </a:xfrm>
+          <a:prstGeom prst="rect">
+            <a:avLst/>
+          </a:prstGeom>
+          <a:noFill/>
+          <a:ln>
+            <a:noFill/>
+          </a:ln>
+        </p:spPr>
+        <p:txBody>
+          <a:bodyPr anchorCtr="0" anchor="t" bIns="0" lIns="0" spcFirstLastPara="1" rIns="0" wrap="square" tIns="0">
+            <a:normAutofit/>
+          </a:bodyPr>
+          <a:lstStyle/>
+          <a:p>
+            <a:pPr indent="0" lvl="0" marL="0" marR="0" rtl="0" algn="l">
+              <a:spcBef>
+                <a:spcPts val="0"/>
+              </a:spcBef>
+              <a:spcAft>
+                <a:spcPts val="0"/>
+              </a:spcAft>
+              <a:buNone/>
+            </a:pPr>
+            <a:r>
+              <a:rPr lang="en-US" sz="1900">
+                <a:solidFill>
+                  <a:srgbClr val="F2F2EF"/>
+                </a:solidFill>
+                <a:latin typeface="Helvetica Neue"/>
+                <a:ea typeface="Helvetica Neue"/>
+                <a:cs typeface="Helvetica Neue"/>
+                <a:sym typeface="Helvetica Neue"/>
+              </a:rPr>
+              <a:t>Make the app useful</a:t>
+            </a:r>
+            <a:endParaRPr/>
+          </a:p>
+        </p:txBody>
+      </p:sp>
+      <p:sp>
+        <p:nvSpPr>
+          <p:cNvPr id="249" name="Google Shape;249;p9"/>
+          <p:cNvSpPr/>
+          <p:nvPr/>
+        </p:nvSpPr>
+        <p:spPr>
+          <a:xfrm>
+            <a:off x="4498848" y="4361688"/>
+            <a:ext cx="3200400" cy="1207008"/>
+          </a:xfrm>
+          <a:prstGeom prst="rect">
+            <a:avLst/>
+          </a:prstGeom>
+          <a:noFill/>
+          <a:ln>
+            <a:noFill/>
+          </a:ln>
+        </p:spPr>
+        <p:txBody>
+          <a:bodyPr anchorCtr="0" anchor="t" bIns="0" lIns="0" spcFirstLastPara="1" rIns="0" wrap="square" tIns="0">
+            <a:normAutofit/>
+          </a:bodyPr>
+          <a:lstStyle/>
+          <a:p>
+            <a:pPr indent="0" lvl="0" marL="0" marR="0" rtl="0" algn="l">
+              <a:spcBef>
+                <a:spcPts val="0"/>
+              </a:spcBef>
+              <a:spcAft>
+                <a:spcPts val="0"/>
+              </a:spcAft>
+              <a:buNone/>
+            </a:pPr>
+            <a:r>
+              <a:rPr lang="en-US" sz="1200">
+                <a:solidFill>
+                  <a:srgbClr val="8B98A8"/>
+                </a:solidFill>
+                <a:latin typeface="Helvetica Neue"/>
+                <a:ea typeface="Helvetica Neue"/>
+                <a:cs typeface="Helvetica Neue"/>
+                <a:sym typeface="Helvetica Neue"/>
+              </a:rPr>
+              <a:t>Better alerts and replays, then test with actual users</a:t>
+            </a:r>
+            <a:endParaRPr/>
+          </a:p>
+        </p:txBody>
+      </p:sp>
+      <p:sp>
+        <p:nvSpPr>
+          <p:cNvPr id="250" name="Google Shape;250;p9"/>
+          <p:cNvSpPr/>
+          <p:nvPr/>
+        </p:nvSpPr>
+        <p:spPr>
+          <a:xfrm>
+            <a:off x="8211312" y="2459736"/>
+            <a:ext cx="3337560" cy="64008"/>
+          </a:xfrm>
+          <a:prstGeom prst="rect">
+            <a:avLst/>
+          </a:prstGeom>
+          <a:solidFill>
+            <a:srgbClr val="F14C1B"/>
+          </a:solidFill>
+          <a:ln cap="flat" cmpd="sng" w="12700">
+            <a:solidFill>
+              <a:srgbClr val="F14C1B">
+                <a:alpha val="0"/>
+              </a:srgbClr>
+            </a:solidFill>
+            <a:prstDash val="solid"/>
+            <a:round/>
+            <a:headEnd len="sm" w="sm" type="none"/>
+            <a:tailEnd len="sm" w="sm" type="none"/>
+          </a:ln>
+        </p:spPr>
+        <p:txBody>
+          <a:bodyPr anchorCtr="0" anchor="t" bIns="45700" lIns="91425" spcFirstLastPara="1" rIns="91425" wrap="square" tIns="45700">
+            <a:noAutofit/>
+          </a:bodyPr>
+          <a:lstStyle/>
+          <a:p>
+            <a:pPr indent="0" lvl="0" marL="0" marR="0" rtl="0" algn="l">
+              <a:spcBef>
+                <a:spcPts val="0"/>
+              </a:spcBef>
+              <a:spcAft>
+                <a:spcPts val="0"/>
+              </a:spcAft>
+              <a:buNone/>
+            </a:pPr>
+            <a:r>
+              <a:t/>
+            </a:r>
+            <a:endParaRPr sz="1800">
+              <a:solidFill>
+                <a:schemeClr val="dk1"/>
+              </a:solidFill>
+              <a:latin typeface="Inter"/>
+              <a:ea typeface="Inter"/>
+              <a:cs typeface="Inter"/>
+              <a:sym typeface="Inter"/>
+            </a:endParaRPr>
+          </a:p>
+        </p:txBody>
+      </p:sp>
+      <p:sp>
+        <p:nvSpPr>
+          <p:cNvPr id="251" name="Google Shape;251;p9"/>
+          <p:cNvSpPr/>
+          <p:nvPr/>
+        </p:nvSpPr>
+        <p:spPr>
+          <a:xfrm>
+            <a:off x="8211312" y="2697480"/>
+            <a:ext cx="3236976" cy="274320"/>
+          </a:xfrm>
+          <a:prstGeom prst="rect">
+            <a:avLst/>
+          </a:prstGeom>
+          <a:noFill/>
+          <a:ln>
+            <a:noFill/>
+          </a:ln>
+        </p:spPr>
+        <p:txBody>
+          <a:bodyPr anchorCtr="0" anchor="ctr" bIns="0" lIns="0" spcFirstLastPara="1" rIns="0" wrap="square" tIns="0">
+            <a:normAutofit/>
+          </a:bodyPr>
+          <a:lstStyle/>
+          <a:p>
+            <a:pPr indent="0" lvl="0" marL="0" marR="0" rtl="0" algn="l">
+              <a:spcBef>
+                <a:spcPts val="0"/>
+              </a:spcBef>
+              <a:spcAft>
+                <a:spcPts val="0"/>
+              </a:spcAft>
+              <a:buNone/>
+            </a:pPr>
+            <a:r>
+              <a:rPr lang="en-US" sz="1000">
+                <a:solidFill>
+                  <a:srgbClr val="F14C1B"/>
+                </a:solidFill>
+                <a:latin typeface="Helvetica Neue"/>
+                <a:ea typeface="Helvetica Neue"/>
+                <a:cs typeface="Helvetica Neue"/>
+                <a:sym typeface="Helvetica Neue"/>
+              </a:rPr>
+              <a:t>LONGER TERM  /  3–6 MONTHS</a:t>
+            </a:r>
+            <a:endParaRPr/>
+          </a:p>
+        </p:txBody>
+      </p:sp>
+      <p:sp>
+        <p:nvSpPr>
+          <p:cNvPr id="252" name="Google Shape;252;p9"/>
+          <p:cNvSpPr/>
+          <p:nvPr/>
+        </p:nvSpPr>
+        <p:spPr>
+          <a:xfrm>
+            <a:off x="8211312" y="3209544"/>
+            <a:ext cx="3255264" cy="905256"/>
+          </a:xfrm>
+          <a:prstGeom prst="rect">
+            <a:avLst/>
+          </a:prstGeom>
+          <a:noFill/>
+          <a:ln>
+            <a:noFill/>
+          </a:ln>
+        </p:spPr>
+        <p:txBody>
+          <a:bodyPr anchorCtr="0" anchor="t" bIns="0" lIns="0" spcFirstLastPara="1" rIns="0" wrap="square" tIns="0">
+            <a:normAutofit/>
+          </a:bodyPr>
+          <a:lstStyle/>
+          <a:p>
+            <a:pPr indent="0" lvl="0" marL="0" marR="0" rtl="0" algn="l">
+              <a:spcBef>
+                <a:spcPts val="0"/>
+              </a:spcBef>
+              <a:spcAft>
+                <a:spcPts val="0"/>
+              </a:spcAft>
+              <a:buNone/>
+            </a:pPr>
+            <a:r>
+              <a:rPr lang="en-US" sz="1900">
+                <a:solidFill>
+                  <a:srgbClr val="F2F2EF"/>
+                </a:solidFill>
+                <a:latin typeface="Helvetica Neue"/>
+                <a:ea typeface="Helvetica Neue"/>
+                <a:cs typeface="Helvetica Neue"/>
+                <a:sym typeface="Helvetica Neue"/>
+              </a:rPr>
+              <a:t>Try another category</a:t>
+            </a:r>
+            <a:endParaRPr/>
+          </a:p>
+        </p:txBody>
+      </p:sp>
+      <p:sp>
+        <p:nvSpPr>
+          <p:cNvPr id="253" name="Google Shape;253;p9"/>
+          <p:cNvSpPr/>
+          <p:nvPr/>
+        </p:nvSpPr>
+        <p:spPr>
+          <a:xfrm>
+            <a:off x="8211312" y="4361688"/>
+            <a:ext cx="3200400" cy="1207008"/>
+          </a:xfrm>
+          <a:prstGeom prst="rect">
+            <a:avLst/>
+          </a:prstGeom>
+          <a:noFill/>
+          <a:ln>
+            <a:noFill/>
+          </a:ln>
+        </p:spPr>
+        <p:txBody>
+          <a:bodyPr anchorCtr="0" anchor="t" bIns="0" lIns="0" spcFirstLastPara="1" rIns="0" wrap="square" tIns="0">
+            <a:normAutofit/>
+          </a:bodyPr>
+          <a:lstStyle/>
+          <a:p>
+            <a:pPr indent="0" lvl="0" marL="0" marR="0" rtl="0" algn="l">
+              <a:spcBef>
+                <a:spcPts val="0"/>
+              </a:spcBef>
+              <a:spcAft>
+                <a:spcPts val="0"/>
+              </a:spcAft>
+              <a:buNone/>
+            </a:pPr>
+            <a:r>
+              <a:rPr lang="en-US" sz="1200">
+                <a:solidFill>
+                  <a:srgbClr val="8B98A8"/>
+                </a:solidFill>
+                <a:latin typeface="Helvetica Neue"/>
+                <a:ea typeface="Helvetica Neue"/>
+                <a:cs typeface="Helvetica Neue"/>
+                <a:sym typeface="Helvetica Neue"/>
+              </a:rPr>
+              <a:t>Start with economic or weather releases and compare market reactions</a:t>
+            </a:r>
+            <a:endParaRPr/>
+          </a:p>
+        </p:txBody>
+      </p:sp>
+    </p:spTree>
+  </p:cSld>
+  <p:clrMapOvr>
+    <a:masterClrMapping/>
+  </p:clrMapOvr>
+</p:sld>
+</file>
+
+<file path=ppt/slides/slide2.xml><?xml version="1.0" encoding="utf-8"?>
+<p:sld xmlns:a="http://schemas.openxmlformats.org/drawingml/2006/main" xmlns:p="http://schemas.openxmlformats.org/presentationml/2006/main" xmlns:r="http://schemas.openxmlformats.org/officeDocument/2006/relationships">
+  <p:cSld>
+    <p:spTree>
+      <p:nvGrpSpPr>
+        <p:cNvPr id="1" name=""/>
+        <p:cNvGrpSpPr/>
+        <p:nvPr/>
+      </p:nvGrpSpPr>
+      <p:grpSpPr/>
+      <p:sp>
+        <p:nvSpPr>
+          <p:cNvPr id="16" name="Google Shape;16;p1"/>
+          <p:cNvSpPr/>
+          <p:nvPr/>
+        </p:nvSpPr>
+        <p:spPr>
+          <a:xfrm>
+            <a:off x="694944" y="612648"/>
+            <a:ext cx="9144000" cy="219456"/>
+          </a:xfrm>
+          <a:prstGeom prst="rect">
+            <a:avLst/>
+          </a:prstGeom>
+          <a:noFill/>
+          <a:ln>
+            <a:noFill/>
+          </a:ln>
+        </p:spPr>
+        <p:txBody>
+          <a:bodyPr anchorCtr="0" anchor="ctr" bIns="0" lIns="0" spcFirstLastPara="1" rIns="0" wrap="square" tIns="0">
+            <a:normAutofit/>
+          </a:bodyPr>
+          <a:lstStyle/>
+          <a:p>
+            <a:pPr indent="0" lvl="0" marL="0" marR="0" rtl="0" algn="l">
+              <a:spcBef>
+                <a:spcPts val="0"/>
+              </a:spcBef>
+              <a:spcAft>
+                <a:spcPts val="0"/>
+              </a:spcAft>
+              <a:buNone/>
+            </a:pPr>
+            <a:r>
+              <a:rPr b="0" i="0" lang="en-US" sz="1100" u="none" cap="none" strike="noStrike">
+                <a:solidFill>
+                  <a:srgbClr val="8B98A8"/>
+                </a:solidFill>
+                <a:latin typeface="Helvetica Neue"/>
+                <a:ea typeface="Helvetica Neue"/>
+                <a:cs typeface="Helvetica Neue"/>
+                <a:sym typeface="Helvetica Neue"/>
+              </a:rPr>
+              <a:t>PLAY THE VIDEO  ·  41 SECONDS</a:t>
+            </a:r>
+            <a:endParaRPr/>
+          </a:p>
+        </p:txBody>
+      </p:sp>
+      <p:sp>
+        <p:nvSpPr>
+          <p:cNvPr id="17" name="Google Shape;17;p1"/>
+          <p:cNvSpPr/>
+          <p:nvPr/>
+        </p:nvSpPr>
+        <p:spPr>
+          <a:xfrm>
+            <a:off x="685800" y="1581912"/>
+            <a:ext cx="9784080" cy="2468880"/>
+          </a:xfrm>
+          <a:prstGeom prst="rect">
+            <a:avLst/>
+          </a:prstGeom>
+          <a:noFill/>
+          <a:ln>
+            <a:noFill/>
+          </a:ln>
+        </p:spPr>
+        <p:txBody>
+          <a:bodyPr anchorCtr="0" anchor="ctr" bIns="0" lIns="0" spcFirstLastPara="1" rIns="0" wrap="square" tIns="0">
+            <a:normAutofit/>
+          </a:bodyPr>
+          <a:lstStyle/>
+          <a:p>
+            <a:pPr indent="0" lvl="0" marL="0" marR="0" rtl="0" algn="l">
+              <a:spcBef>
+                <a:spcPts val="0"/>
+              </a:spcBef>
+              <a:spcAft>
+                <a:spcPts val="0"/>
+              </a:spcAft>
+              <a:buClr>
+                <a:srgbClr val="F2F2EF"/>
+              </a:buClr>
+              <a:buSzPts val="5700"/>
+              <a:buFont typeface="Helvetica Neue"/>
+              <a:buNone/>
+            </a:pPr>
+            <a:r>
+              <a:rPr b="1" i="0" lang="en-US" sz="5700" u="none" cap="none" strike="noStrike">
+                <a:solidFill>
+                  <a:srgbClr val="F2F2EF"/>
+                </a:solidFill>
+                <a:latin typeface="Helvetica Neue"/>
+                <a:ea typeface="Helvetica Neue"/>
+                <a:cs typeface="Helvetica Neue"/>
+                <a:sym typeface="Helvetica Neue"/>
+              </a:rPr>
+              <a:t>▶  Kalshi Knows in 41 seconds</a:t>
+            </a:r>
+            <a:endParaRPr b="0" i="0" sz="6600" u="none" cap="none" strike="noStrike">
+              <a:solidFill>
+                <a:schemeClr val="dk1"/>
+              </a:solidFill>
+              <a:latin typeface="Inter"/>
+              <a:ea typeface="Inter"/>
+              <a:cs typeface="Inter"/>
+              <a:sym typeface="Inter"/>
+            </a:endParaRPr>
+          </a:p>
+          <a:p>
+            <a:pPr indent="0" lvl="0" marL="0" marR="0" rtl="0" algn="l">
+              <a:spcBef>
+                <a:spcPts val="0"/>
+              </a:spcBef>
+              <a:spcAft>
+                <a:spcPts val="0"/>
+              </a:spcAft>
+              <a:buClr>
+                <a:srgbClr val="F2F2EF"/>
+              </a:buClr>
+              <a:buSzPts val="5700"/>
+              <a:buFont typeface="Helvetica Neue"/>
+              <a:buNone/>
+            </a:pPr>
+            <a:r>
+              <a:rPr b="1" i="0" lang="en-US" sz="5700" u="none" cap="none" strike="noStrike">
+                <a:solidFill>
+                  <a:srgbClr val="F2F2EF"/>
+                </a:solidFill>
+                <a:latin typeface="Helvetica Neue"/>
+                <a:ea typeface="Helvetica Neue"/>
+                <a:cs typeface="Helvetica Neue"/>
+                <a:sym typeface="Helvetica Neue"/>
+              </a:rPr>
+              <a:t>first?</a:t>
+            </a:r>
+            <a:endParaRPr b="0" i="0" sz="6600" u="none" cap="none" strike="noStrike">
+              <a:solidFill>
+                <a:schemeClr val="dk1"/>
+              </a:solidFill>
+              <a:latin typeface="Inter"/>
+              <a:ea typeface="Inter"/>
+              <a:cs typeface="Inter"/>
+              <a:sym typeface="Inter"/>
+            </a:endParaRPr>
+          </a:p>
+        </p:txBody>
+      </p:sp>
+      <p:sp>
+        <p:nvSpPr>
+          <p:cNvPr id="18" name="Google Shape;18;p1"/>
+          <p:cNvSpPr/>
+          <p:nvPr/>
+        </p:nvSpPr>
+        <p:spPr>
+          <a:xfrm>
+            <a:off x="694944" y="4379976"/>
+            <a:ext cx="978408" cy="64008"/>
+          </a:xfrm>
+          <a:prstGeom prst="rect">
+            <a:avLst/>
+          </a:prstGeom>
+          <a:solidFill>
+            <a:srgbClr val="F14C1B"/>
+          </a:solidFill>
+          <a:ln cap="flat" cmpd="sng" w="12700">
+            <a:solidFill>
+              <a:srgbClr val="F14C1B">
+                <a:alpha val="0"/>
+              </a:srgbClr>
+            </a:solidFill>
+            <a:prstDash val="solid"/>
+            <a:round/>
+            <a:headEnd len="sm" w="sm" type="none"/>
+            <a:tailEnd len="sm" w="sm" type="none"/>
+          </a:ln>
+        </p:spPr>
+        <p:txBody>
+          <a:bodyPr anchorCtr="0" anchor="t" bIns="45700" lIns="91425" spcFirstLastPara="1" rIns="91425" wrap="square" tIns="45700">
+            <a:noAutofit/>
+          </a:bodyPr>
+          <a:lstStyle/>
+          <a:p>
+            <a:pPr indent="0" lvl="0" marL="0" marR="0" rtl="0" algn="l">
+              <a:spcBef>
+                <a:spcPts val="0"/>
+              </a:spcBef>
+              <a:spcAft>
+                <a:spcPts val="0"/>
+              </a:spcAft>
+              <a:buNone/>
+            </a:pPr>
+            <a:r>
+              <a:t/>
+            </a:r>
+            <a:endParaRPr sz="1800">
+              <a:solidFill>
+                <a:schemeClr val="dk1"/>
+              </a:solidFill>
+              <a:latin typeface="Inter"/>
+              <a:ea typeface="Inter"/>
+              <a:cs typeface="Inter"/>
+              <a:sym typeface="Inter"/>
+            </a:endParaRPr>
+          </a:p>
+        </p:txBody>
+      </p:sp>
+      <p:sp>
+        <p:nvSpPr>
           <p:cNvPr id="19" name="Google Shape;19;p1"/>
           <p:cNvSpPr/>
           <p:nvPr/>
@@ -4467,7 +6077,7 @@
 </p:sld>
 </file>
 
-<file path=ppt/slides/slide2.xml><?xml version="1.0" encoding="utf-8"?>
+<file path=ppt/slides/slide3.xml><?xml version="1.0" encoding="utf-8"?>
 <p:sld xmlns:a="http://schemas.openxmlformats.org/drawingml/2006/main" xmlns:r="http://schemas.openxmlformats.org/officeDocument/2006/relationships" xmlns:mc="http://schemas.openxmlformats.org/markup-compatibility/2006" xmlns:mv="urn:schemas-microsoft-com:mac:vml" xmlns:p="http://schemas.openxmlformats.org/presentationml/2006/main" xmlns:c="http://schemas.openxmlformats.org/drawingml/2006/chart" xmlns:dgm="http://schemas.openxmlformats.org/drawingml/2006/diagram" xmlns:o="urn:schemas-microsoft-com:office:office" xmlns:v="urn:schemas-microsoft-com:vml" xmlns:pvml="urn:schemas-microsoft-com:office:powerpoint" xmlns:com="http://schemas.openxmlformats.org/drawingml/2006/compatibility" xmlns:p14="http://schemas.microsoft.com/office/powerpoint/2010/main" xmlns:p15="http://schemas.microsoft.com/office/powerpoint/2012/main" xmlns:ahyp="http://schemas.microsoft.com/office/drawing/2018/hyperlinkcolor">
   <p:cSld>
     <p:bg>
@@ -5199,7 +6809,7 @@
 </p:sld>
 </file>
 
-<file path=ppt/slides/slide3.xml><?xml version="1.0" encoding="utf-8"?>
+<file path=ppt/slides/slide4.xml><?xml version="1.0" encoding="utf-8"?>
 <p:sld xmlns:a="http://schemas.openxmlformats.org/drawingml/2006/main" xmlns:r="http://schemas.openxmlformats.org/officeDocument/2006/relationships" xmlns:mc="http://schemas.openxmlformats.org/markup-compatibility/2006" xmlns:mv="urn:schemas-microsoft-com:mac:vml" xmlns:p="http://schemas.openxmlformats.org/presentationml/2006/main" xmlns:c="http://schemas.openxmlformats.org/drawingml/2006/chart" xmlns:dgm="http://schemas.openxmlformats.org/drawingml/2006/diagram" xmlns:o="urn:schemas-microsoft-com:office:office" xmlns:v="urn:schemas-microsoft-com:vml" xmlns:pvml="urn:schemas-microsoft-com:office:powerpoint" xmlns:com="http://schemas.openxmlformats.org/drawingml/2006/compatibility" xmlns:p14="http://schemas.microsoft.com/office/powerpoint/2010/main" xmlns:p15="http://schemas.microsoft.com/office/powerpoint/2012/main" xmlns:ahyp="http://schemas.microsoft.com/office/drawing/2018/hyperlinkcolor">
   <p:cSld>
     <p:bg>
@@ -6206,7 +7816,7 @@
 </p:sld>
 </file>
 
-<file path=ppt/slides/slide4.xml><?xml version="1.0" encoding="utf-8"?>
+<file path=ppt/slides/slide5.xml><?xml version="1.0" encoding="utf-8"?>
 <p:sld xmlns:a="http://schemas.openxmlformats.org/drawingml/2006/main" xmlns:r="http://schemas.openxmlformats.org/officeDocument/2006/relationships" xmlns:mc="http://schemas.openxmlformats.org/markup-compatibility/2006" xmlns:mv="urn:schemas-microsoft-com:mac:vml" xmlns:p="http://schemas.openxmlformats.org/presentationml/2006/main" xmlns:c="http://schemas.openxmlformats.org/drawingml/2006/chart" xmlns:dgm="http://schemas.openxmlformats.org/drawingml/2006/diagram" xmlns:o="urn:schemas-microsoft-com:office:office" xmlns:v="urn:schemas-microsoft-com:vml" xmlns:pvml="urn:schemas-microsoft-com:office:powerpoint" xmlns:com="http://schemas.openxmlformats.org/drawingml/2006/compatibility" xmlns:p14="http://schemas.microsoft.com/office/powerpoint/2010/main" xmlns:p15="http://schemas.microsoft.com/office/powerpoint/2012/main" xmlns:ahyp="http://schemas.microsoft.com/office/drawing/2018/hyperlinkcolor">
   <p:cSld>
     <p:bg>
@@ -7216,7 +8826,7 @@
 </p:sld>
 </file>
 
-<file path=ppt/slides/slide5.xml><?xml version="1.0" encoding="utf-8"?>
+<file path=ppt/slides/slide6.xml><?xml version="1.0" encoding="utf-8"?>
 <p:sld xmlns:a="http://schemas.openxmlformats.org/drawingml/2006/main" xmlns:r="http://schemas.openxmlformats.org/officeDocument/2006/relationships" xmlns:mc="http://schemas.openxmlformats.org/markup-compatibility/2006" xmlns:mv="urn:schemas-microsoft-com:mac:vml" xmlns:p="http://schemas.openxmlformats.org/presentationml/2006/main" xmlns:c="http://schemas.openxmlformats.org/drawingml/2006/chart" xmlns:dgm="http://schemas.openxmlformats.org/drawingml/2006/diagram" xmlns:o="urn:schemas-microsoft-com:office:office" xmlns:v="urn:schemas-microsoft-com:vml" xmlns:pvml="urn:schemas-microsoft-com:office:powerpoint" xmlns:com="http://schemas.openxmlformats.org/drawingml/2006/compatibility" xmlns:p14="http://schemas.microsoft.com/office/powerpoint/2010/main" xmlns:p15="http://schemas.microsoft.com/office/powerpoint/2012/main" xmlns:ahyp="http://schemas.microsoft.com/office/drawing/2018/hyperlinkcolor">
   <p:cSld>
     <p:bg>
@@ -8048,7 +9658,7 @@
 </p:sld>
 </file>
 
-<file path=ppt/slides/slide6.xml><?xml version="1.0" encoding="utf-8"?>
+<file path=ppt/slides/slide7.xml><?xml version="1.0" encoding="utf-8"?>
 <p:sld xmlns:a="http://schemas.openxmlformats.org/drawingml/2006/main" xmlns:r="http://schemas.openxmlformats.org/officeDocument/2006/relationships" xmlns:mc="http://schemas.openxmlformats.org/markup-compatibility/2006" xmlns:mv="urn:schemas-microsoft-com:mac:vml" xmlns:p="http://schemas.openxmlformats.org/presentationml/2006/main" xmlns:c="http://schemas.openxmlformats.org/drawingml/2006/chart" xmlns:dgm="http://schemas.openxmlformats.org/drawingml/2006/diagram" xmlns:o="urn:schemas-microsoft-com:office:office" xmlns:v="urn:schemas-microsoft-com:vml" xmlns:pvml="urn:schemas-microsoft-com:office:powerpoint" xmlns:com="http://schemas.openxmlformats.org/drawingml/2006/compatibility" xmlns:p14="http://schemas.microsoft.com/office/powerpoint/2010/main" xmlns:p15="http://schemas.microsoft.com/office/powerpoint/2012/main" xmlns:ahyp="http://schemas.microsoft.com/office/drawing/2018/hyperlinkcolor">
   <p:cSld>
     <p:bg>
@@ -9058,7 +10668,7 @@
 </p:sld>
 </file>
 
-<file path=ppt/slides/slide7.xml><?xml version="1.0" encoding="utf-8"?>
+<file path=ppt/slides/slide8.xml><?xml version="1.0" encoding="utf-8"?>
 <p:sld xmlns:a="http://schemas.openxmlformats.org/drawingml/2006/main" xmlns:r="http://schemas.openxmlformats.org/officeDocument/2006/relationships" xmlns:mc="http://schemas.openxmlformats.org/markup-compatibility/2006" xmlns:mv="urn:schemas-microsoft-com:mac:vml" xmlns:p="http://schemas.openxmlformats.org/presentationml/2006/main" xmlns:c="http://schemas.openxmlformats.org/drawingml/2006/chart" xmlns:dgm="http://schemas.openxmlformats.org/drawingml/2006/diagram" xmlns:o="urn:schemas-microsoft-com:office:office" xmlns:v="urn:schemas-microsoft-com:vml" xmlns:pvml="urn:schemas-microsoft-com:office:powerpoint" xmlns:com="http://schemas.openxmlformats.org/drawingml/2006/compatibility" xmlns:p14="http://schemas.microsoft.com/office/powerpoint/2010/main" xmlns:p15="http://schemas.microsoft.com/office/powerpoint/2012/main" xmlns:ahyp="http://schemas.microsoft.com/office/drawing/2018/hyperlinkcolor">
   <p:cSld>
     <p:bg>
@@ -10786,7 +12396,7 @@
                 <a:cs typeface="Helvetica Neue"/>
                 <a:sym typeface="Helvetica Neue"/>
               </a:rPr>
-              <a:t>POLITICS</a:t>
+              <a:t>CRYPTO</a:t>
             </a:r>
             <a:endParaRPr sz="1200">
               <a:solidFill>
@@ -10844,7 +12454,7 @@
                 <a:cs typeface="Helvetica Neue"/>
                 <a:sym typeface="Helvetica Neue"/>
               </a:rPr>
-              <a:t>Results and poll releases</a:t>
+              <a:t>Prices and exchange data</a:t>
             </a:r>
             <a:endParaRPr/>
           </a:p>
@@ -10894,7 +12504,7 @@
                 <a:cs typeface="Helvetica Neue"/>
                 <a:sym typeface="Helvetica Neue"/>
               </a:rPr>
-              <a:t>Odds vs reported results</a:t>
+              <a:t>Crash / spike alerts</a:t>
             </a:r>
             <a:endParaRPr/>
           </a:p>
@@ -10944,7 +12554,7 @@
                 <a:cs typeface="Helvetica Neue"/>
                 <a:sym typeface="Helvetica Neue"/>
               </a:rPr>
-              <a:t>Journalists / researchers</a:t>
+              <a:t>Traders</a:t>
             </a:r>
             <a:endParaRPr/>
           </a:p>
@@ -11436,7 +13046,7 @@
 </p:sld>
 </file>
 
-<file path=ppt/slides/slide8.xml><?xml version="1.0" encoding="utf-8"?>
+<file path=ppt/slides/slide9.xml><?xml version="1.0" encoding="utf-8"?>
 <p:sld xmlns:a="http://schemas.openxmlformats.org/drawingml/2006/main" xmlns:r="http://schemas.openxmlformats.org/officeDocument/2006/relationships" xmlns:mc="http://schemas.openxmlformats.org/markup-compatibility/2006" xmlns:mv="urn:schemas-microsoft-com:mac:vml" xmlns:p="http://schemas.openxmlformats.org/presentationml/2006/main" xmlns:c="http://schemas.openxmlformats.org/drawingml/2006/chart" xmlns:dgm="http://schemas.openxmlformats.org/drawingml/2006/diagram" xmlns:o="urn:schemas-microsoft-com:office:office" xmlns:v="urn:schemas-microsoft-com:vml" xmlns:pvml="urn:schemas-microsoft-com:office:powerpoint" xmlns:com="http://schemas.openxmlformats.org/drawingml/2006/compatibility" xmlns:p14="http://schemas.microsoft.com/office/powerpoint/2010/main" xmlns:p15="http://schemas.microsoft.com/office/powerpoint/2012/main" xmlns:ahyp="http://schemas.microsoft.com/office/drawing/2018/hyperlinkcolor">
   <p:cSld>
     <p:bg>
@@ -13183,1616 +14793,6 @@
                 <a:sym typeface="Helvetica Neue"/>
               </a:rPr>
               <a:t>Talk to trading firms and exchanges before building this</a:t>
-            </a:r>
-            <a:endParaRPr/>
-          </a:p>
-        </p:txBody>
-      </p:sp>
-    </p:spTree>
-  </p:cSld>
-  <p:clrMapOvr>
-    <a:masterClrMapping/>
-  </p:clrMapOvr>
-</p:sld>
-</file>
-
-<file path=ppt/slides/slide9.xml><?xml version="1.0" encoding="utf-8"?>
-<p:sld xmlns:a="http://schemas.openxmlformats.org/drawingml/2006/main" xmlns:r="http://schemas.openxmlformats.org/officeDocument/2006/relationships" xmlns:mc="http://schemas.openxmlformats.org/markup-compatibility/2006" xmlns:mv="urn:schemas-microsoft-com:mac:vml" xmlns:p="http://schemas.openxmlformats.org/presentationml/2006/main" xmlns:c="http://schemas.openxmlformats.org/drawingml/2006/chart" xmlns:dgm="http://schemas.openxmlformats.org/drawingml/2006/diagram" xmlns:o="urn:schemas-microsoft-com:office:office" xmlns:v="urn:schemas-microsoft-com:vml" xmlns:pvml="urn:schemas-microsoft-com:office:powerpoint" xmlns:com="http://schemas.openxmlformats.org/drawingml/2006/compatibility" xmlns:p14="http://schemas.microsoft.com/office/powerpoint/2010/main" xmlns:p15="http://schemas.microsoft.com/office/powerpoint/2012/main" xmlns:ahyp="http://schemas.microsoft.com/office/drawing/2018/hyperlinkcolor">
-  <p:cSld>
-    <p:bg>
-      <p:bgPr>
-        <a:solidFill>
-          <a:srgbClr val="0C0E10"/>
-        </a:solidFill>
-      </p:bgPr>
-    </p:bg>
-    <p:spTree>
-      <p:nvGrpSpPr>
-        <p:cNvPr id="224" name="Shape 224"/>
-        <p:cNvGrpSpPr/>
-        <p:nvPr/>
-      </p:nvGrpSpPr>
-      <p:grpSpPr>
-        <a:xfrm>
-          <a:off x="0" y="0"/>
-          <a:ext cx="0" cy="0"/>
-          <a:chOff x="0" y="0"/>
-          <a:chExt cx="0" cy="0"/>
-        </a:xfrm>
-      </p:grpSpPr>
-      <p:sp>
-        <p:nvSpPr>
-          <p:cNvPr id="225" name="Google Shape;225;p9"/>
-          <p:cNvSpPr/>
-          <p:nvPr/>
-        </p:nvSpPr>
-        <p:spPr>
-          <a:xfrm>
-            <a:off x="685800" y="347472"/>
-            <a:ext cx="329184" cy="50292"/>
-          </a:xfrm>
-          <a:prstGeom prst="rect">
-            <a:avLst/>
-          </a:prstGeom>
-          <a:solidFill>
-            <a:srgbClr val="F14C1B"/>
-          </a:solidFill>
-          <a:ln cap="flat" cmpd="sng" w="12700">
-            <a:solidFill>
-              <a:srgbClr val="F14C1B">
-                <a:alpha val="0"/>
-              </a:srgbClr>
-            </a:solidFill>
-            <a:prstDash val="solid"/>
-            <a:round/>
-            <a:headEnd len="sm" w="sm" type="none"/>
-            <a:tailEnd len="sm" w="sm" type="none"/>
-          </a:ln>
-        </p:spPr>
-        <p:txBody>
-          <a:bodyPr anchorCtr="0" anchor="t" bIns="45700" lIns="91425" spcFirstLastPara="1" rIns="91425" wrap="square" tIns="45700">
-            <a:noAutofit/>
-          </a:bodyPr>
-          <a:lstStyle/>
-          <a:p>
-            <a:pPr indent="0" lvl="0" marL="0" marR="0" rtl="0" algn="l">
-              <a:spcBef>
-                <a:spcPts val="0"/>
-              </a:spcBef>
-              <a:spcAft>
-                <a:spcPts val="0"/>
-              </a:spcAft>
-              <a:buNone/>
-            </a:pPr>
-            <a:r>
-              <a:t/>
-            </a:r>
-            <a:endParaRPr sz="1800">
-              <a:solidFill>
-                <a:schemeClr val="dk1"/>
-              </a:solidFill>
-              <a:latin typeface="Inter"/>
-              <a:ea typeface="Inter"/>
-              <a:cs typeface="Inter"/>
-              <a:sym typeface="Inter"/>
-            </a:endParaRPr>
-          </a:p>
-        </p:txBody>
-      </p:sp>
-      <p:sp>
-        <p:nvSpPr>
-          <p:cNvPr id="226" name="Google Shape;226;p9"/>
-          <p:cNvSpPr/>
-          <p:nvPr/>
-        </p:nvSpPr>
-        <p:spPr>
-          <a:xfrm>
-            <a:off x="685800" y="182880"/>
-            <a:ext cx="7772400" cy="164592"/>
-          </a:xfrm>
-          <a:prstGeom prst="rect">
-            <a:avLst/>
-          </a:prstGeom>
-          <a:noFill/>
-          <a:ln>
-            <a:noFill/>
-          </a:ln>
-        </p:spPr>
-        <p:txBody>
-          <a:bodyPr anchorCtr="0" anchor="ctr" bIns="0" lIns="0" spcFirstLastPara="1" rIns="0" wrap="square" tIns="0">
-            <a:normAutofit/>
-          </a:bodyPr>
-          <a:lstStyle/>
-          <a:p>
-            <a:pPr indent="0" lvl="0" marL="0" marR="0" rtl="0" algn="l">
-              <a:spcBef>
-                <a:spcPts val="0"/>
-              </a:spcBef>
-              <a:spcAft>
-                <a:spcPts val="0"/>
-              </a:spcAft>
-              <a:buClr>
-                <a:srgbClr val="8B98A8"/>
-              </a:buClr>
-              <a:buSzPts val="880"/>
-              <a:buFont typeface="Helvetica Neue"/>
-              <a:buNone/>
-            </a:pPr>
-            <a:r>
-              <a:rPr b="1" lang="en-US" sz="880">
-                <a:solidFill>
-                  <a:srgbClr val="8B98A8"/>
-                </a:solidFill>
-                <a:latin typeface="Helvetica Neue"/>
-                <a:ea typeface="Helvetica Neue"/>
-                <a:cs typeface="Helvetica Neue"/>
-                <a:sym typeface="Helvetica Neue"/>
-              </a:rPr>
-              <a:t>KALSHI KNOWS  /  NEXT</a:t>
-            </a:r>
-            <a:endParaRPr sz="880">
-              <a:solidFill>
-                <a:schemeClr val="dk1"/>
-              </a:solidFill>
-              <a:latin typeface="Inter"/>
-              <a:ea typeface="Inter"/>
-              <a:cs typeface="Inter"/>
-              <a:sym typeface="Inter"/>
-            </a:endParaRPr>
-          </a:p>
-        </p:txBody>
-      </p:sp>
-      <p:sp>
-        <p:nvSpPr>
-          <p:cNvPr id="227" name="Google Shape;227;p9"/>
-          <p:cNvSpPr/>
-          <p:nvPr/>
-        </p:nvSpPr>
-        <p:spPr>
-          <a:xfrm>
-            <a:off x="676656" y="649224"/>
-            <a:ext cx="10927080" cy="1143000"/>
-          </a:xfrm>
-          <a:prstGeom prst="rect">
-            <a:avLst/>
-          </a:prstGeom>
-          <a:noFill/>
-          <a:ln>
-            <a:noFill/>
-          </a:ln>
-        </p:spPr>
-        <p:txBody>
-          <a:bodyPr anchorCtr="0" anchor="t" bIns="0" lIns="4550" spcFirstLastPara="1" rIns="0" wrap="square" tIns="0">
-            <a:normAutofit/>
-          </a:bodyPr>
-          <a:lstStyle/>
-          <a:p>
-            <a:pPr indent="0" lvl="0" marL="0" marR="0" rtl="0" algn="l">
-              <a:spcBef>
-                <a:spcPts val="0"/>
-              </a:spcBef>
-              <a:spcAft>
-                <a:spcPts val="0"/>
-              </a:spcAft>
-              <a:buNone/>
-            </a:pPr>
-            <a:r>
-              <a:rPr lang="en-US" sz="3100">
-                <a:solidFill>
-                  <a:srgbClr val="F2F2EF"/>
-                </a:solidFill>
-                <a:latin typeface="Helvetica Neue"/>
-                <a:ea typeface="Helvetica Neue"/>
-                <a:cs typeface="Helvetica Neue"/>
-                <a:sym typeface="Helvetica Neue"/>
-              </a:rPr>
-              <a:t>Next: every market, a decade of data, RL on profit.</a:t>
-            </a:r>
-            <a:endParaRPr/>
-          </a:p>
-        </p:txBody>
-      </p:sp>
-      <p:sp>
-        <p:nvSpPr>
-          <p:cNvPr id="228" name="Google Shape;228;p9"/>
-          <p:cNvSpPr/>
-          <p:nvPr/>
-        </p:nvSpPr>
-        <p:spPr>
-          <a:xfrm>
-            <a:off x="704088" y="1627632"/>
-            <a:ext cx="10808208" cy="320040"/>
-          </a:xfrm>
-          <a:prstGeom prst="rect">
-            <a:avLst/>
-          </a:prstGeom>
-          <a:noFill/>
-          <a:ln>
-            <a:noFill/>
-          </a:ln>
-        </p:spPr>
-        <p:txBody>
-          <a:bodyPr anchorCtr="0" anchor="t" bIns="0" lIns="0" spcFirstLastPara="1" rIns="0" wrap="square" tIns="0">
-            <a:normAutofit/>
-          </a:bodyPr>
-          <a:lstStyle/>
-          <a:p>
-            <a:pPr indent="0" lvl="0" marL="0" marR="0" rtl="0" algn="l">
-              <a:spcBef>
-                <a:spcPts val="0"/>
-              </a:spcBef>
-              <a:spcAft>
-                <a:spcPts val="0"/>
-              </a:spcAft>
-              <a:buNone/>
-            </a:pPr>
-            <a:r>
-              <a:rPr lang="en-US" sz="1300">
-                <a:solidFill>
-                  <a:srgbClr val="8B98A8"/>
-                </a:solidFill>
-                <a:latin typeface="Helvetica Neue"/>
-                <a:ea typeface="Helvetica Neue"/>
-                <a:cs typeface="Helvetica Neue"/>
-                <a:sym typeface="Helvetica Neue"/>
-              </a:rPr>
-              <a:t>Train on 4.36M+ settled markets (Kalshi + Polymarket) with reinforcement learning; today we were limited by compute and training time</a:t>
-            </a:r>
-            <a:endParaRPr/>
-          </a:p>
-        </p:txBody>
-      </p:sp>
-      <p:cxnSp>
-        <p:nvCxnSpPr>
-          <p:cNvPr id="229" name="Google Shape;229;p9"/>
-          <p:cNvCxnSpPr/>
-          <p:nvPr/>
-        </p:nvCxnSpPr>
-        <p:spPr>
-          <a:xfrm>
-            <a:off x="640080" y="6373368"/>
-            <a:ext cx="10927080" cy="0"/>
-          </a:xfrm>
-          <a:prstGeom prst="straightConnector1">
-            <a:avLst/>
-          </a:prstGeom>
-          <a:noFill/>
-          <a:ln cap="flat" cmpd="sng" w="9525">
-            <a:solidFill>
-              <a:srgbClr val="32383E"/>
-            </a:solidFill>
-            <a:prstDash val="solid"/>
-            <a:round/>
-            <a:headEnd len="sm" w="sm" type="none"/>
-            <a:tailEnd len="sm" w="sm" type="none"/>
-          </a:ln>
-        </p:spPr>
-      </p:cxnSp>
-      <p:pic>
-        <p:nvPicPr>
-          <p:cNvPr descr="/mnt/data/kalshi_knows_rebuilt/assets/vss_mark_dark.png" id="230" name="Google Shape;230;p9"/>
-          <p:cNvPicPr preferRelativeResize="0"/>
-          <p:nvPr/>
-        </p:nvPicPr>
-        <p:blipFill rotWithShape="1">
-          <a:blip r:embed="rId3">
-            <a:alphaModFix/>
-          </a:blip>
-          <a:srcRect b="0" l="0" r="0" t="0"/>
-          <a:stretch/>
-        </p:blipFill>
-        <p:spPr>
-          <a:xfrm>
-            <a:off x="621792" y="6432804"/>
-            <a:ext cx="283464" cy="228600"/>
-          </a:xfrm>
-          <a:prstGeom prst="rect">
-            <a:avLst/>
-          </a:prstGeom>
-          <a:noFill/>
-          <a:ln>
-            <a:noFill/>
-          </a:ln>
-        </p:spPr>
-      </p:pic>
-      <p:sp>
-        <p:nvSpPr>
-          <p:cNvPr id="231" name="Google Shape;231;p9"/>
-          <p:cNvSpPr/>
-          <p:nvPr/>
-        </p:nvSpPr>
-        <p:spPr>
-          <a:xfrm>
-            <a:off x="1005840" y="6423660"/>
-            <a:ext cx="1600200" cy="182880"/>
-          </a:xfrm>
-          <a:prstGeom prst="rect">
-            <a:avLst/>
-          </a:prstGeom>
-          <a:noFill/>
-          <a:ln>
-            <a:noFill/>
-          </a:ln>
-        </p:spPr>
-        <p:txBody>
-          <a:bodyPr anchorCtr="0" anchor="ctr" bIns="0" lIns="0" spcFirstLastPara="1" rIns="0" wrap="square" tIns="0">
-            <a:normAutofit/>
-          </a:bodyPr>
-          <a:lstStyle/>
-          <a:p>
-            <a:pPr indent="0" lvl="0" marL="0" marR="0" rtl="0" algn="l">
-              <a:spcBef>
-                <a:spcPts val="0"/>
-              </a:spcBef>
-              <a:spcAft>
-                <a:spcPts val="0"/>
-              </a:spcAft>
-              <a:buClr>
-                <a:srgbClr val="8B98A8"/>
-              </a:buClr>
-              <a:buSzPts val="820"/>
-              <a:buFont typeface="Helvetica Neue"/>
-              <a:buNone/>
-            </a:pPr>
-            <a:r>
-              <a:rPr b="1" lang="en-US" sz="820">
-                <a:solidFill>
-                  <a:srgbClr val="8B98A8"/>
-                </a:solidFill>
-                <a:latin typeface="Helvetica Neue"/>
-                <a:ea typeface="Helvetica Neue"/>
-                <a:cs typeface="Helvetica Neue"/>
-                <a:sym typeface="Helvetica Neue"/>
-              </a:rPr>
-              <a:t>KALSHI KNOWS</a:t>
-            </a:r>
-            <a:endParaRPr sz="820">
-              <a:solidFill>
-                <a:schemeClr val="dk1"/>
-              </a:solidFill>
-              <a:latin typeface="Inter"/>
-              <a:ea typeface="Inter"/>
-              <a:cs typeface="Inter"/>
-              <a:sym typeface="Inter"/>
-            </a:endParaRPr>
-          </a:p>
-        </p:txBody>
-      </p:sp>
-      <p:sp>
-        <p:nvSpPr>
-          <p:cNvPr id="232" name="Google Shape;232;p9"/>
-          <p:cNvSpPr/>
-          <p:nvPr/>
-        </p:nvSpPr>
-        <p:spPr>
-          <a:xfrm>
-            <a:off x="3931920" y="6437376"/>
-            <a:ext cx="969264" cy="164592"/>
-          </a:xfrm>
-          <a:prstGeom prst="rect">
-            <a:avLst/>
-          </a:prstGeom>
-          <a:noFill/>
-          <a:ln>
-            <a:noFill/>
-          </a:ln>
-        </p:spPr>
-        <p:txBody>
-          <a:bodyPr anchorCtr="0" anchor="ctr" bIns="0" lIns="0" spcFirstLastPara="1" rIns="0" wrap="square" tIns="0">
-            <a:normAutofit/>
-          </a:bodyPr>
-          <a:lstStyle/>
-          <a:p>
-            <a:pPr indent="0" lvl="0" marL="0" marR="0" rtl="0" algn="ctr">
-              <a:spcBef>
-                <a:spcPts val="0"/>
-              </a:spcBef>
-              <a:spcAft>
-                <a:spcPts val="0"/>
-              </a:spcAft>
-              <a:buClr>
-                <a:srgbClr val="8B98A8"/>
-              </a:buClr>
-              <a:buSzPts val="780"/>
-              <a:buFont typeface="Helvetica Neue"/>
-              <a:buNone/>
-            </a:pPr>
-            <a:r>
-              <a:rPr lang="en-US" sz="780">
-                <a:solidFill>
-                  <a:srgbClr val="8B98A8"/>
-                </a:solidFill>
-                <a:latin typeface="Helvetica Neue"/>
-                <a:ea typeface="Helvetica Neue"/>
-                <a:cs typeface="Helvetica Neue"/>
-                <a:sym typeface="Helvetica Neue"/>
-              </a:rPr>
-              <a:t>QUESTION</a:t>
-            </a:r>
-            <a:endParaRPr sz="780">
-              <a:solidFill>
-                <a:schemeClr val="dk1"/>
-              </a:solidFill>
-              <a:latin typeface="Inter"/>
-              <a:ea typeface="Inter"/>
-              <a:cs typeface="Inter"/>
-              <a:sym typeface="Inter"/>
-            </a:endParaRPr>
-          </a:p>
-        </p:txBody>
-      </p:sp>
-      <p:sp>
-        <p:nvSpPr>
-          <p:cNvPr id="233" name="Google Shape;233;p9"/>
-          <p:cNvSpPr/>
-          <p:nvPr/>
-        </p:nvSpPr>
-        <p:spPr>
-          <a:xfrm>
-            <a:off x="4946904" y="6437376"/>
-            <a:ext cx="969264" cy="164592"/>
-          </a:xfrm>
-          <a:prstGeom prst="rect">
-            <a:avLst/>
-          </a:prstGeom>
-          <a:noFill/>
-          <a:ln>
-            <a:noFill/>
-          </a:ln>
-        </p:spPr>
-        <p:txBody>
-          <a:bodyPr anchorCtr="0" anchor="ctr" bIns="0" lIns="0" spcFirstLastPara="1" rIns="0" wrap="square" tIns="0">
-            <a:normAutofit/>
-          </a:bodyPr>
-          <a:lstStyle/>
-          <a:p>
-            <a:pPr indent="0" lvl="0" marL="0" marR="0" rtl="0" algn="ctr">
-              <a:spcBef>
-                <a:spcPts val="0"/>
-              </a:spcBef>
-              <a:spcAft>
-                <a:spcPts val="0"/>
-              </a:spcAft>
-              <a:buClr>
-                <a:srgbClr val="8B98A8"/>
-              </a:buClr>
-              <a:buSzPts val="780"/>
-              <a:buFont typeface="Helvetica Neue"/>
-              <a:buNone/>
-            </a:pPr>
-            <a:r>
-              <a:rPr lang="en-US" sz="780">
-                <a:solidFill>
-                  <a:srgbClr val="8B98A8"/>
-                </a:solidFill>
-                <a:latin typeface="Helvetica Neue"/>
-                <a:ea typeface="Helvetica Neue"/>
-                <a:cs typeface="Helvetica Neue"/>
-                <a:sym typeface="Helvetica Neue"/>
-              </a:rPr>
-              <a:t>PROTOTYPE</a:t>
-            </a:r>
-            <a:endParaRPr sz="780">
-              <a:solidFill>
-                <a:schemeClr val="dk1"/>
-              </a:solidFill>
-              <a:latin typeface="Inter"/>
-              <a:ea typeface="Inter"/>
-              <a:cs typeface="Inter"/>
-              <a:sym typeface="Inter"/>
-            </a:endParaRPr>
-          </a:p>
-        </p:txBody>
-      </p:sp>
-      <p:sp>
-        <p:nvSpPr>
-          <p:cNvPr id="234" name="Google Shape;234;p9"/>
-          <p:cNvSpPr/>
-          <p:nvPr/>
-        </p:nvSpPr>
-        <p:spPr>
-          <a:xfrm>
-            <a:off x="5961888" y="6437376"/>
-            <a:ext cx="969264" cy="164592"/>
-          </a:xfrm>
-          <a:prstGeom prst="rect">
-            <a:avLst/>
-          </a:prstGeom>
-          <a:noFill/>
-          <a:ln>
-            <a:noFill/>
-          </a:ln>
-        </p:spPr>
-        <p:txBody>
-          <a:bodyPr anchorCtr="0" anchor="ctr" bIns="0" lIns="0" spcFirstLastPara="1" rIns="0" wrap="square" tIns="0">
-            <a:normAutofit/>
-          </a:bodyPr>
-          <a:lstStyle/>
-          <a:p>
-            <a:pPr indent="0" lvl="0" marL="0" marR="0" rtl="0" algn="ctr">
-              <a:spcBef>
-                <a:spcPts val="0"/>
-              </a:spcBef>
-              <a:spcAft>
-                <a:spcPts val="0"/>
-              </a:spcAft>
-              <a:buClr>
-                <a:srgbClr val="8B98A8"/>
-              </a:buClr>
-              <a:buSzPts val="780"/>
-              <a:buFont typeface="Helvetica Neue"/>
-              <a:buNone/>
-            </a:pPr>
-            <a:r>
-              <a:rPr lang="en-US" sz="780">
-                <a:solidFill>
-                  <a:srgbClr val="8B98A8"/>
-                </a:solidFill>
-                <a:latin typeface="Helvetica Neue"/>
-                <a:ea typeface="Helvetica Neue"/>
-                <a:cs typeface="Helvetica Neue"/>
-                <a:sym typeface="Helvetica Neue"/>
-              </a:rPr>
-              <a:t>EVIDENCE</a:t>
-            </a:r>
-            <a:endParaRPr sz="780">
-              <a:solidFill>
-                <a:schemeClr val="dk1"/>
-              </a:solidFill>
-              <a:latin typeface="Inter"/>
-              <a:ea typeface="Inter"/>
-              <a:cs typeface="Inter"/>
-              <a:sym typeface="Inter"/>
-            </a:endParaRPr>
-          </a:p>
-        </p:txBody>
-      </p:sp>
-      <p:sp>
-        <p:nvSpPr>
-          <p:cNvPr id="235" name="Google Shape;235;p9"/>
-          <p:cNvSpPr/>
-          <p:nvPr/>
-        </p:nvSpPr>
-        <p:spPr>
-          <a:xfrm>
-            <a:off x="6976872" y="6437376"/>
-            <a:ext cx="969264" cy="164592"/>
-          </a:xfrm>
-          <a:prstGeom prst="rect">
-            <a:avLst/>
-          </a:prstGeom>
-          <a:noFill/>
-          <a:ln>
-            <a:noFill/>
-          </a:ln>
-        </p:spPr>
-        <p:txBody>
-          <a:bodyPr anchorCtr="0" anchor="ctr" bIns="0" lIns="0" spcFirstLastPara="1" rIns="0" wrap="square" tIns="0">
-            <a:normAutofit/>
-          </a:bodyPr>
-          <a:lstStyle/>
-          <a:p>
-            <a:pPr indent="0" lvl="0" marL="0" marR="0" rtl="0" algn="ctr">
-              <a:spcBef>
-                <a:spcPts val="0"/>
-              </a:spcBef>
-              <a:spcAft>
-                <a:spcPts val="0"/>
-              </a:spcAft>
-              <a:buClr>
-                <a:srgbClr val="8B98A8"/>
-              </a:buClr>
-              <a:buSzPts val="780"/>
-              <a:buFont typeface="Helvetica Neue"/>
-              <a:buNone/>
-            </a:pPr>
-            <a:r>
-              <a:rPr lang="en-US" sz="780">
-                <a:solidFill>
-                  <a:srgbClr val="8B98A8"/>
-                </a:solidFill>
-                <a:latin typeface="Helvetica Neue"/>
-                <a:ea typeface="Helvetica Neue"/>
-                <a:cs typeface="Helvetica Neue"/>
-                <a:sym typeface="Helvetica Neue"/>
-              </a:rPr>
-              <a:t>MARKET</a:t>
-            </a:r>
-            <a:endParaRPr sz="780">
-              <a:solidFill>
-                <a:schemeClr val="dk1"/>
-              </a:solidFill>
-              <a:latin typeface="Inter"/>
-              <a:ea typeface="Inter"/>
-              <a:cs typeface="Inter"/>
-              <a:sym typeface="Inter"/>
-            </a:endParaRPr>
-          </a:p>
-        </p:txBody>
-      </p:sp>
-      <p:sp>
-        <p:nvSpPr>
-          <p:cNvPr id="236" name="Google Shape;236;p9"/>
-          <p:cNvSpPr/>
-          <p:nvPr/>
-        </p:nvSpPr>
-        <p:spPr>
-          <a:xfrm>
-            <a:off x="7991856" y="6437376"/>
-            <a:ext cx="969264" cy="164592"/>
-          </a:xfrm>
-          <a:prstGeom prst="rect">
-            <a:avLst/>
-          </a:prstGeom>
-          <a:noFill/>
-          <a:ln>
-            <a:noFill/>
-          </a:ln>
-        </p:spPr>
-        <p:txBody>
-          <a:bodyPr anchorCtr="0" anchor="ctr" bIns="0" lIns="0" spcFirstLastPara="1" rIns="0" wrap="square" tIns="0">
-            <a:normAutofit/>
-          </a:bodyPr>
-          <a:lstStyle/>
-          <a:p>
-            <a:pPr indent="0" lvl="0" marL="0" marR="0" rtl="0" algn="ctr">
-              <a:spcBef>
-                <a:spcPts val="0"/>
-              </a:spcBef>
-              <a:spcAft>
-                <a:spcPts val="0"/>
-              </a:spcAft>
-              <a:buClr>
-                <a:srgbClr val="8B98A8"/>
-              </a:buClr>
-              <a:buSzPts val="780"/>
-              <a:buFont typeface="Helvetica Neue"/>
-              <a:buNone/>
-            </a:pPr>
-            <a:r>
-              <a:rPr lang="en-US" sz="780">
-                <a:solidFill>
-                  <a:srgbClr val="8B98A8"/>
-                </a:solidFill>
-                <a:latin typeface="Helvetica Neue"/>
-                <a:ea typeface="Helvetica Neue"/>
-                <a:cs typeface="Helvetica Neue"/>
-                <a:sym typeface="Helvetica Neue"/>
-              </a:rPr>
-              <a:t>EXPANSION</a:t>
-            </a:r>
-            <a:endParaRPr sz="780">
-              <a:solidFill>
-                <a:schemeClr val="dk1"/>
-              </a:solidFill>
-              <a:latin typeface="Inter"/>
-              <a:ea typeface="Inter"/>
-              <a:cs typeface="Inter"/>
-              <a:sym typeface="Inter"/>
-            </a:endParaRPr>
-          </a:p>
-        </p:txBody>
-      </p:sp>
-      <p:sp>
-        <p:nvSpPr>
-          <p:cNvPr id="237" name="Google Shape;237;p9"/>
-          <p:cNvSpPr/>
-          <p:nvPr/>
-        </p:nvSpPr>
-        <p:spPr>
-          <a:xfrm>
-            <a:off x="9006840" y="6437376"/>
-            <a:ext cx="969264" cy="164592"/>
-          </a:xfrm>
-          <a:prstGeom prst="rect">
-            <a:avLst/>
-          </a:prstGeom>
-          <a:noFill/>
-          <a:ln>
-            <a:noFill/>
-          </a:ln>
-        </p:spPr>
-        <p:txBody>
-          <a:bodyPr anchorCtr="0" anchor="ctr" bIns="0" lIns="0" spcFirstLastPara="1" rIns="0" wrap="square" tIns="0">
-            <a:normAutofit/>
-          </a:bodyPr>
-          <a:lstStyle/>
-          <a:p>
-            <a:pPr indent="0" lvl="0" marL="0" marR="0" rtl="0" algn="ctr">
-              <a:spcBef>
-                <a:spcPts val="0"/>
-              </a:spcBef>
-              <a:spcAft>
-                <a:spcPts val="0"/>
-              </a:spcAft>
-              <a:buClr>
-                <a:srgbClr val="8B98A8"/>
-              </a:buClr>
-              <a:buSzPts val="780"/>
-              <a:buFont typeface="Helvetica Neue"/>
-              <a:buNone/>
-            </a:pPr>
-            <a:r>
-              <a:rPr lang="en-US" sz="780">
-                <a:solidFill>
-                  <a:srgbClr val="8B98A8"/>
-                </a:solidFill>
-                <a:latin typeface="Helvetica Neue"/>
-                <a:ea typeface="Helvetica Neue"/>
-                <a:cs typeface="Helvetica Neue"/>
-                <a:sym typeface="Helvetica Neue"/>
-              </a:rPr>
-              <a:t>BUSINESS</a:t>
-            </a:r>
-            <a:endParaRPr sz="780">
-              <a:solidFill>
-                <a:schemeClr val="dk1"/>
-              </a:solidFill>
-              <a:latin typeface="Inter"/>
-              <a:ea typeface="Inter"/>
-              <a:cs typeface="Inter"/>
-              <a:sym typeface="Inter"/>
-            </a:endParaRPr>
-          </a:p>
-        </p:txBody>
-      </p:sp>
-      <p:sp>
-        <p:nvSpPr>
-          <p:cNvPr id="238" name="Google Shape;238;p9"/>
-          <p:cNvSpPr/>
-          <p:nvPr/>
-        </p:nvSpPr>
-        <p:spPr>
-          <a:xfrm>
-            <a:off x="10021824" y="6437376"/>
-            <a:ext cx="969264" cy="164592"/>
-          </a:xfrm>
-          <a:prstGeom prst="rect">
-            <a:avLst/>
-          </a:prstGeom>
-          <a:noFill/>
-          <a:ln>
-            <a:noFill/>
-          </a:ln>
-        </p:spPr>
-        <p:txBody>
-          <a:bodyPr anchorCtr="0" anchor="ctr" bIns="0" lIns="0" spcFirstLastPara="1" rIns="0" wrap="square" tIns="0">
-            <a:normAutofit/>
-          </a:bodyPr>
-          <a:lstStyle/>
-          <a:p>
-            <a:pPr indent="0" lvl="0" marL="0" marR="0" rtl="0" algn="ctr">
-              <a:spcBef>
-                <a:spcPts val="0"/>
-              </a:spcBef>
-              <a:spcAft>
-                <a:spcPts val="0"/>
-              </a:spcAft>
-              <a:buClr>
-                <a:srgbClr val="F2F2EF"/>
-              </a:buClr>
-              <a:buSzPts val="780"/>
-              <a:buFont typeface="Helvetica Neue"/>
-              <a:buNone/>
-            </a:pPr>
-            <a:r>
-              <a:rPr b="1" lang="en-US" sz="780">
-                <a:solidFill>
-                  <a:srgbClr val="F2F2EF"/>
-                </a:solidFill>
-                <a:latin typeface="Helvetica Neue"/>
-                <a:ea typeface="Helvetica Neue"/>
-                <a:cs typeface="Helvetica Neue"/>
-                <a:sym typeface="Helvetica Neue"/>
-              </a:rPr>
-              <a:t>NEXT</a:t>
-            </a:r>
-            <a:endParaRPr sz="780">
-              <a:solidFill>
-                <a:schemeClr val="dk1"/>
-              </a:solidFill>
-              <a:latin typeface="Inter"/>
-              <a:ea typeface="Inter"/>
-              <a:cs typeface="Inter"/>
-              <a:sym typeface="Inter"/>
-            </a:endParaRPr>
-          </a:p>
-        </p:txBody>
-      </p:sp>
-      <p:sp>
-        <p:nvSpPr>
-          <p:cNvPr id="239" name="Google Shape;239;p9"/>
-          <p:cNvSpPr/>
-          <p:nvPr/>
-        </p:nvSpPr>
-        <p:spPr>
-          <a:xfrm>
-            <a:off x="10021824" y="6364224"/>
-            <a:ext cx="960120" cy="22860"/>
-          </a:xfrm>
-          <a:prstGeom prst="rect">
-            <a:avLst/>
-          </a:prstGeom>
-          <a:solidFill>
-            <a:srgbClr val="F14C1B"/>
-          </a:solidFill>
-          <a:ln cap="flat" cmpd="sng" w="12700">
-            <a:solidFill>
-              <a:srgbClr val="F14C1B">
-                <a:alpha val="0"/>
-              </a:srgbClr>
-            </a:solidFill>
-            <a:prstDash val="solid"/>
-            <a:round/>
-            <a:headEnd len="sm" w="sm" type="none"/>
-            <a:tailEnd len="sm" w="sm" type="none"/>
-          </a:ln>
-        </p:spPr>
-        <p:txBody>
-          <a:bodyPr anchorCtr="0" anchor="t" bIns="45700" lIns="91425" spcFirstLastPara="1" rIns="91425" wrap="square" tIns="45700">
-            <a:noAutofit/>
-          </a:bodyPr>
-          <a:lstStyle/>
-          <a:p>
-            <a:pPr indent="0" lvl="0" marL="0" marR="0" rtl="0" algn="l">
-              <a:spcBef>
-                <a:spcPts val="0"/>
-              </a:spcBef>
-              <a:spcAft>
-                <a:spcPts val="0"/>
-              </a:spcAft>
-              <a:buNone/>
-            </a:pPr>
-            <a:r>
-              <a:t/>
-            </a:r>
-            <a:endParaRPr sz="1800">
-              <a:solidFill>
-                <a:schemeClr val="dk1"/>
-              </a:solidFill>
-              <a:latin typeface="Inter"/>
-              <a:ea typeface="Inter"/>
-              <a:cs typeface="Inter"/>
-              <a:sym typeface="Inter"/>
-            </a:endParaRPr>
-          </a:p>
-        </p:txBody>
-      </p:sp>
-      <p:sp>
-        <p:nvSpPr>
-          <p:cNvPr id="240" name="Google Shape;240;p9"/>
-          <p:cNvSpPr/>
-          <p:nvPr/>
-        </p:nvSpPr>
-        <p:spPr>
-          <a:xfrm>
-            <a:off x="11320272" y="6423660"/>
-            <a:ext cx="210312" cy="201168"/>
-          </a:xfrm>
-          <a:prstGeom prst="rect">
-            <a:avLst/>
-          </a:prstGeom>
-          <a:noFill/>
-          <a:ln>
-            <a:noFill/>
-          </a:ln>
-        </p:spPr>
-        <p:txBody>
-          <a:bodyPr anchorCtr="0" anchor="ctr" bIns="0" lIns="0" spcFirstLastPara="1" rIns="0" wrap="square" tIns="0">
-            <a:normAutofit/>
-          </a:bodyPr>
-          <a:lstStyle/>
-          <a:p>
-            <a:pPr indent="0" lvl="0" marL="0" marR="0" rtl="0" algn="l">
-              <a:spcBef>
-                <a:spcPts val="0"/>
-              </a:spcBef>
-              <a:spcAft>
-                <a:spcPts val="0"/>
-              </a:spcAft>
-              <a:buNone/>
-            </a:pPr>
-            <a:r>
-              <a:rPr lang="en-US" sz="850">
-                <a:solidFill>
-                  <a:schemeClr val="dk1"/>
-                </a:solidFill>
-                <a:latin typeface="Helvetica Neue"/>
-                <a:ea typeface="Helvetica Neue"/>
-                <a:cs typeface="Helvetica Neue"/>
-                <a:sym typeface="Helvetica Neue"/>
-              </a:rPr>
-              <a:t>10</a:t>
-            </a:r>
-            <a:endParaRPr/>
-          </a:p>
-        </p:txBody>
-      </p:sp>
-      <p:sp>
-        <p:nvSpPr>
-          <p:cNvPr id="241" name="Google Shape;241;p9"/>
-          <p:cNvSpPr/>
-          <p:nvPr/>
-        </p:nvSpPr>
-        <p:spPr>
-          <a:xfrm>
-            <a:off x="704088" y="6153912"/>
-            <a:ext cx="10826496" cy="164592"/>
-          </a:xfrm>
-          <a:prstGeom prst="rect">
-            <a:avLst/>
-          </a:prstGeom>
-          <a:noFill/>
-          <a:ln>
-            <a:noFill/>
-          </a:ln>
-        </p:spPr>
-        <p:txBody>
-          <a:bodyPr anchorCtr="0" anchor="ctr" bIns="0" lIns="0" spcFirstLastPara="1" rIns="0" wrap="square" tIns="0">
-            <a:normAutofit/>
-          </a:bodyPr>
-          <a:lstStyle/>
-          <a:p>
-            <a:pPr indent="0" lvl="0" marL="0" marR="0" rtl="0" algn="l">
-              <a:spcBef>
-                <a:spcPts val="0"/>
-              </a:spcBef>
-              <a:spcAft>
-                <a:spcPts val="0"/>
-              </a:spcAft>
-              <a:buClr>
-                <a:srgbClr val="8B98A8"/>
-              </a:buClr>
-              <a:buSzPts val="810"/>
-              <a:buFont typeface="Helvetica Neue"/>
-              <a:buNone/>
-            </a:pPr>
-            <a:r>
-              <a:rPr lang="en-US" sz="810">
-                <a:solidFill>
-                  <a:srgbClr val="8B98A8"/>
-                </a:solidFill>
-                <a:latin typeface="Helvetica Neue"/>
-                <a:ea typeface="Helvetica Neue"/>
-                <a:cs typeface="Helvetica Neue"/>
-                <a:sym typeface="Helvetica Neue"/>
-              </a:rPr>
-              <a:t>Targets, not results · Public data only · No real money · Not betting advice · 21+ · Gambling problem? 1-800-GAMBLER</a:t>
-            </a:r>
-            <a:endParaRPr sz="715">
-              <a:solidFill>
-                <a:schemeClr val="dk1"/>
-              </a:solidFill>
-              <a:latin typeface="Inter"/>
-              <a:ea typeface="Inter"/>
-              <a:cs typeface="Inter"/>
-              <a:sym typeface="Inter"/>
-            </a:endParaRPr>
-          </a:p>
-        </p:txBody>
-      </p:sp>
-      <p:sp>
-        <p:nvSpPr>
-          <p:cNvPr id="242" name="Google Shape;242;p9"/>
-          <p:cNvSpPr/>
-          <p:nvPr/>
-        </p:nvSpPr>
-        <p:spPr>
-          <a:xfrm>
-            <a:off x="786384" y="2459736"/>
-            <a:ext cx="3337560" cy="64008"/>
-          </a:xfrm>
-          <a:prstGeom prst="rect">
-            <a:avLst/>
-          </a:prstGeom>
-          <a:solidFill>
-            <a:srgbClr val="F14C1B"/>
-          </a:solidFill>
-          <a:ln cap="flat" cmpd="sng" w="12700">
-            <a:solidFill>
-              <a:srgbClr val="F14C1B">
-                <a:alpha val="0"/>
-              </a:srgbClr>
-            </a:solidFill>
-            <a:prstDash val="solid"/>
-            <a:round/>
-            <a:headEnd len="sm" w="sm" type="none"/>
-            <a:tailEnd len="sm" w="sm" type="none"/>
-          </a:ln>
-        </p:spPr>
-        <p:txBody>
-          <a:bodyPr anchorCtr="0" anchor="t" bIns="45700" lIns="91425" spcFirstLastPara="1" rIns="91425" wrap="square" tIns="45700">
-            <a:noAutofit/>
-          </a:bodyPr>
-          <a:lstStyle/>
-          <a:p>
-            <a:pPr indent="0" lvl="0" marL="0" marR="0" rtl="0" algn="l">
-              <a:spcBef>
-                <a:spcPts val="0"/>
-              </a:spcBef>
-              <a:spcAft>
-                <a:spcPts val="0"/>
-              </a:spcAft>
-              <a:buNone/>
-            </a:pPr>
-            <a:r>
-              <a:t/>
-            </a:r>
-            <a:endParaRPr sz="1800">
-              <a:solidFill>
-                <a:schemeClr val="dk1"/>
-              </a:solidFill>
-              <a:latin typeface="Inter"/>
-              <a:ea typeface="Inter"/>
-              <a:cs typeface="Inter"/>
-              <a:sym typeface="Inter"/>
-            </a:endParaRPr>
-          </a:p>
-        </p:txBody>
-      </p:sp>
-      <p:sp>
-        <p:nvSpPr>
-          <p:cNvPr id="243" name="Google Shape;243;p9"/>
-          <p:cNvSpPr/>
-          <p:nvPr/>
-        </p:nvSpPr>
-        <p:spPr>
-          <a:xfrm>
-            <a:off x="786384" y="2697480"/>
-            <a:ext cx="3236976" cy="274320"/>
-          </a:xfrm>
-          <a:prstGeom prst="rect">
-            <a:avLst/>
-          </a:prstGeom>
-          <a:noFill/>
-          <a:ln>
-            <a:noFill/>
-          </a:ln>
-        </p:spPr>
-        <p:txBody>
-          <a:bodyPr anchorCtr="0" anchor="ctr" bIns="0" lIns="0" spcFirstLastPara="1" rIns="0" wrap="square" tIns="0">
-            <a:normAutofit/>
-          </a:bodyPr>
-          <a:lstStyle/>
-          <a:p>
-            <a:pPr indent="0" lvl="0" marL="0" marR="0" rtl="0" algn="l">
-              <a:spcBef>
-                <a:spcPts val="0"/>
-              </a:spcBef>
-              <a:spcAft>
-                <a:spcPts val="0"/>
-              </a:spcAft>
-              <a:buNone/>
-            </a:pPr>
-            <a:r>
-              <a:rPr lang="en-US" sz="1000">
-                <a:solidFill>
-                  <a:srgbClr val="F14C1B"/>
-                </a:solidFill>
-                <a:latin typeface="Helvetica Neue"/>
-                <a:ea typeface="Helvetica Neue"/>
-                <a:cs typeface="Helvetica Neue"/>
-                <a:sym typeface="Helvetica Neue"/>
-              </a:rPr>
-              <a:t>NEXT  /  2 WEEKS</a:t>
-            </a:r>
-            <a:endParaRPr/>
-          </a:p>
-        </p:txBody>
-      </p:sp>
-      <p:sp>
-        <p:nvSpPr>
-          <p:cNvPr id="244" name="Google Shape;244;p9"/>
-          <p:cNvSpPr/>
-          <p:nvPr/>
-        </p:nvSpPr>
-        <p:spPr>
-          <a:xfrm>
-            <a:off x="786384" y="3209544"/>
-            <a:ext cx="3255264" cy="905256"/>
-          </a:xfrm>
-          <a:prstGeom prst="rect">
-            <a:avLst/>
-          </a:prstGeom>
-          <a:noFill/>
-          <a:ln>
-            <a:noFill/>
-          </a:ln>
-        </p:spPr>
-        <p:txBody>
-          <a:bodyPr anchorCtr="0" anchor="t" bIns="0" lIns="0" spcFirstLastPara="1" rIns="0" wrap="square" tIns="0">
-            <a:normAutofit/>
-          </a:bodyPr>
-          <a:lstStyle/>
-          <a:p>
-            <a:pPr indent="0" lvl="0" marL="0" marR="0" rtl="0" algn="l">
-              <a:spcBef>
-                <a:spcPts val="0"/>
-              </a:spcBef>
-              <a:spcAft>
-                <a:spcPts val="0"/>
-              </a:spcAft>
-              <a:buNone/>
-            </a:pPr>
-            <a:r>
-              <a:rPr lang="en-US" sz="1900">
-                <a:solidFill>
-                  <a:srgbClr val="F2F2EF"/>
-                </a:solidFill>
-                <a:latin typeface="Helvetica Neue"/>
-                <a:ea typeface="Helvetica Neue"/>
-                <a:cs typeface="Helvetica Neue"/>
-                <a:sym typeface="Helvetica Neue"/>
-              </a:rPr>
-              <a:t>Test on new games</a:t>
-            </a:r>
-            <a:endParaRPr/>
-          </a:p>
-        </p:txBody>
-      </p:sp>
-      <p:sp>
-        <p:nvSpPr>
-          <p:cNvPr id="245" name="Google Shape;245;p9"/>
-          <p:cNvSpPr/>
-          <p:nvPr/>
-        </p:nvSpPr>
-        <p:spPr>
-          <a:xfrm>
-            <a:off x="786384" y="4361688"/>
-            <a:ext cx="3200400" cy="1207008"/>
-          </a:xfrm>
-          <a:prstGeom prst="rect">
-            <a:avLst/>
-          </a:prstGeom>
-          <a:noFill/>
-          <a:ln>
-            <a:noFill/>
-          </a:ln>
-        </p:spPr>
-        <p:txBody>
-          <a:bodyPr anchorCtr="0" anchor="t" bIns="0" lIns="0" spcFirstLastPara="1" rIns="0" wrap="square" tIns="0">
-            <a:normAutofit/>
-          </a:bodyPr>
-          <a:lstStyle/>
-          <a:p>
-            <a:pPr indent="0" lvl="0" marL="0" marR="0" rtl="0" algn="l">
-              <a:spcBef>
-                <a:spcPts val="0"/>
-              </a:spcBef>
-              <a:spcAft>
-                <a:spcPts val="0"/>
-              </a:spcAft>
-              <a:buNone/>
-            </a:pPr>
-            <a:r>
-              <a:rPr lang="en-US" sz="1200">
-                <a:solidFill>
-                  <a:srgbClr val="8B98A8"/>
-                </a:solidFill>
-                <a:latin typeface="Helvetica Neue"/>
-                <a:ea typeface="Helvetica Neue"/>
-                <a:cs typeface="Helvetica Neue"/>
-                <a:sym typeface="Helvetica Neue"/>
-              </a:rPr>
-              <a:t>Record every alert, check the timing and count false alarms</a:t>
-            </a:r>
-            <a:endParaRPr/>
-          </a:p>
-        </p:txBody>
-      </p:sp>
-      <p:sp>
-        <p:nvSpPr>
-          <p:cNvPr id="246" name="Google Shape;246;p9"/>
-          <p:cNvSpPr/>
-          <p:nvPr/>
-        </p:nvSpPr>
-        <p:spPr>
-          <a:xfrm>
-            <a:off x="4498848" y="2459736"/>
-            <a:ext cx="3337560" cy="64008"/>
-          </a:xfrm>
-          <a:prstGeom prst="rect">
-            <a:avLst/>
-          </a:prstGeom>
-          <a:solidFill>
-            <a:srgbClr val="F14C1B"/>
-          </a:solidFill>
-          <a:ln cap="flat" cmpd="sng" w="12700">
-            <a:solidFill>
-              <a:srgbClr val="F14C1B">
-                <a:alpha val="0"/>
-              </a:srgbClr>
-            </a:solidFill>
-            <a:prstDash val="solid"/>
-            <a:round/>
-            <a:headEnd len="sm" w="sm" type="none"/>
-            <a:tailEnd len="sm" w="sm" type="none"/>
-          </a:ln>
-        </p:spPr>
-        <p:txBody>
-          <a:bodyPr anchorCtr="0" anchor="t" bIns="45700" lIns="91425" spcFirstLastPara="1" rIns="91425" wrap="square" tIns="45700">
-            <a:noAutofit/>
-          </a:bodyPr>
-          <a:lstStyle/>
-          <a:p>
-            <a:pPr indent="0" lvl="0" marL="0" marR="0" rtl="0" algn="l">
-              <a:spcBef>
-                <a:spcPts val="0"/>
-              </a:spcBef>
-              <a:spcAft>
-                <a:spcPts val="0"/>
-              </a:spcAft>
-              <a:buNone/>
-            </a:pPr>
-            <a:r>
-              <a:t/>
-            </a:r>
-            <a:endParaRPr sz="1800">
-              <a:solidFill>
-                <a:schemeClr val="dk1"/>
-              </a:solidFill>
-              <a:latin typeface="Inter"/>
-              <a:ea typeface="Inter"/>
-              <a:cs typeface="Inter"/>
-              <a:sym typeface="Inter"/>
-            </a:endParaRPr>
-          </a:p>
-        </p:txBody>
-      </p:sp>
-      <p:sp>
-        <p:nvSpPr>
-          <p:cNvPr id="247" name="Google Shape;247;p9"/>
-          <p:cNvSpPr/>
-          <p:nvPr/>
-        </p:nvSpPr>
-        <p:spPr>
-          <a:xfrm>
-            <a:off x="4498848" y="2697480"/>
-            <a:ext cx="3236976" cy="274320"/>
-          </a:xfrm>
-          <a:prstGeom prst="rect">
-            <a:avLst/>
-          </a:prstGeom>
-          <a:noFill/>
-          <a:ln>
-            <a:noFill/>
-          </a:ln>
-        </p:spPr>
-        <p:txBody>
-          <a:bodyPr anchorCtr="0" anchor="ctr" bIns="0" lIns="0" spcFirstLastPara="1" rIns="0" wrap="square" tIns="0">
-            <a:normAutofit/>
-          </a:bodyPr>
-          <a:lstStyle/>
-          <a:p>
-            <a:pPr indent="0" lvl="0" marL="0" marR="0" rtl="0" algn="l">
-              <a:spcBef>
-                <a:spcPts val="0"/>
-              </a:spcBef>
-              <a:spcAft>
-                <a:spcPts val="0"/>
-              </a:spcAft>
-              <a:buNone/>
-            </a:pPr>
-            <a:r>
-              <a:rPr lang="en-US" sz="1000">
-                <a:solidFill>
-                  <a:srgbClr val="F14C1B"/>
-                </a:solidFill>
-                <a:latin typeface="Helvetica Neue"/>
-                <a:ea typeface="Helvetica Neue"/>
-                <a:cs typeface="Helvetica Neue"/>
-                <a:sym typeface="Helvetica Neue"/>
-              </a:rPr>
-              <a:t>AFTER THAT  /  1–3 MONTHS</a:t>
-            </a:r>
-            <a:endParaRPr/>
-          </a:p>
-        </p:txBody>
-      </p:sp>
-      <p:sp>
-        <p:nvSpPr>
-          <p:cNvPr id="248" name="Google Shape;248;p9"/>
-          <p:cNvSpPr/>
-          <p:nvPr/>
-        </p:nvSpPr>
-        <p:spPr>
-          <a:xfrm>
-            <a:off x="4498848" y="3209544"/>
-            <a:ext cx="3255264" cy="905256"/>
-          </a:xfrm>
-          <a:prstGeom prst="rect">
-            <a:avLst/>
-          </a:prstGeom>
-          <a:noFill/>
-          <a:ln>
-            <a:noFill/>
-          </a:ln>
-        </p:spPr>
-        <p:txBody>
-          <a:bodyPr anchorCtr="0" anchor="t" bIns="0" lIns="0" spcFirstLastPara="1" rIns="0" wrap="square" tIns="0">
-            <a:normAutofit/>
-          </a:bodyPr>
-          <a:lstStyle/>
-          <a:p>
-            <a:pPr indent="0" lvl="0" marL="0" marR="0" rtl="0" algn="l">
-              <a:spcBef>
-                <a:spcPts val="0"/>
-              </a:spcBef>
-              <a:spcAft>
-                <a:spcPts val="0"/>
-              </a:spcAft>
-              <a:buNone/>
-            </a:pPr>
-            <a:r>
-              <a:rPr lang="en-US" sz="1900">
-                <a:solidFill>
-                  <a:srgbClr val="F2F2EF"/>
-                </a:solidFill>
-                <a:latin typeface="Helvetica Neue"/>
-                <a:ea typeface="Helvetica Neue"/>
-                <a:cs typeface="Helvetica Neue"/>
-                <a:sym typeface="Helvetica Neue"/>
-              </a:rPr>
-              <a:t>Make the app useful</a:t>
-            </a:r>
-            <a:endParaRPr/>
-          </a:p>
-        </p:txBody>
-      </p:sp>
-      <p:sp>
-        <p:nvSpPr>
-          <p:cNvPr id="249" name="Google Shape;249;p9"/>
-          <p:cNvSpPr/>
-          <p:nvPr/>
-        </p:nvSpPr>
-        <p:spPr>
-          <a:xfrm>
-            <a:off x="4498848" y="4361688"/>
-            <a:ext cx="3200400" cy="1207008"/>
-          </a:xfrm>
-          <a:prstGeom prst="rect">
-            <a:avLst/>
-          </a:prstGeom>
-          <a:noFill/>
-          <a:ln>
-            <a:noFill/>
-          </a:ln>
-        </p:spPr>
-        <p:txBody>
-          <a:bodyPr anchorCtr="0" anchor="t" bIns="0" lIns="0" spcFirstLastPara="1" rIns="0" wrap="square" tIns="0">
-            <a:normAutofit/>
-          </a:bodyPr>
-          <a:lstStyle/>
-          <a:p>
-            <a:pPr indent="0" lvl="0" marL="0" marR="0" rtl="0" algn="l">
-              <a:spcBef>
-                <a:spcPts val="0"/>
-              </a:spcBef>
-              <a:spcAft>
-                <a:spcPts val="0"/>
-              </a:spcAft>
-              <a:buNone/>
-            </a:pPr>
-            <a:r>
-              <a:rPr lang="en-US" sz="1200">
-                <a:solidFill>
-                  <a:srgbClr val="8B98A8"/>
-                </a:solidFill>
-                <a:latin typeface="Helvetica Neue"/>
-                <a:ea typeface="Helvetica Neue"/>
-                <a:cs typeface="Helvetica Neue"/>
-                <a:sym typeface="Helvetica Neue"/>
-              </a:rPr>
-              <a:t>Better alerts and replays, then test with actual users</a:t>
-            </a:r>
-            <a:endParaRPr/>
-          </a:p>
-        </p:txBody>
-      </p:sp>
-      <p:sp>
-        <p:nvSpPr>
-          <p:cNvPr id="250" name="Google Shape;250;p9"/>
-          <p:cNvSpPr/>
-          <p:nvPr/>
-        </p:nvSpPr>
-        <p:spPr>
-          <a:xfrm>
-            <a:off x="8211312" y="2459736"/>
-            <a:ext cx="3337560" cy="64008"/>
-          </a:xfrm>
-          <a:prstGeom prst="rect">
-            <a:avLst/>
-          </a:prstGeom>
-          <a:solidFill>
-            <a:srgbClr val="F14C1B"/>
-          </a:solidFill>
-          <a:ln cap="flat" cmpd="sng" w="12700">
-            <a:solidFill>
-              <a:srgbClr val="F14C1B">
-                <a:alpha val="0"/>
-              </a:srgbClr>
-            </a:solidFill>
-            <a:prstDash val="solid"/>
-            <a:round/>
-            <a:headEnd len="sm" w="sm" type="none"/>
-            <a:tailEnd len="sm" w="sm" type="none"/>
-          </a:ln>
-        </p:spPr>
-        <p:txBody>
-          <a:bodyPr anchorCtr="0" anchor="t" bIns="45700" lIns="91425" spcFirstLastPara="1" rIns="91425" wrap="square" tIns="45700">
-            <a:noAutofit/>
-          </a:bodyPr>
-          <a:lstStyle/>
-          <a:p>
-            <a:pPr indent="0" lvl="0" marL="0" marR="0" rtl="0" algn="l">
-              <a:spcBef>
-                <a:spcPts val="0"/>
-              </a:spcBef>
-              <a:spcAft>
-                <a:spcPts val="0"/>
-              </a:spcAft>
-              <a:buNone/>
-            </a:pPr>
-            <a:r>
-              <a:t/>
-            </a:r>
-            <a:endParaRPr sz="1800">
-              <a:solidFill>
-                <a:schemeClr val="dk1"/>
-              </a:solidFill>
-              <a:latin typeface="Inter"/>
-              <a:ea typeface="Inter"/>
-              <a:cs typeface="Inter"/>
-              <a:sym typeface="Inter"/>
-            </a:endParaRPr>
-          </a:p>
-        </p:txBody>
-      </p:sp>
-      <p:sp>
-        <p:nvSpPr>
-          <p:cNvPr id="251" name="Google Shape;251;p9"/>
-          <p:cNvSpPr/>
-          <p:nvPr/>
-        </p:nvSpPr>
-        <p:spPr>
-          <a:xfrm>
-            <a:off x="8211312" y="2697480"/>
-            <a:ext cx="3236976" cy="274320"/>
-          </a:xfrm>
-          <a:prstGeom prst="rect">
-            <a:avLst/>
-          </a:prstGeom>
-          <a:noFill/>
-          <a:ln>
-            <a:noFill/>
-          </a:ln>
-        </p:spPr>
-        <p:txBody>
-          <a:bodyPr anchorCtr="0" anchor="ctr" bIns="0" lIns="0" spcFirstLastPara="1" rIns="0" wrap="square" tIns="0">
-            <a:normAutofit/>
-          </a:bodyPr>
-          <a:lstStyle/>
-          <a:p>
-            <a:pPr indent="0" lvl="0" marL="0" marR="0" rtl="0" algn="l">
-              <a:spcBef>
-                <a:spcPts val="0"/>
-              </a:spcBef>
-              <a:spcAft>
-                <a:spcPts val="0"/>
-              </a:spcAft>
-              <a:buNone/>
-            </a:pPr>
-            <a:r>
-              <a:rPr lang="en-US" sz="1000">
-                <a:solidFill>
-                  <a:srgbClr val="F14C1B"/>
-                </a:solidFill>
-                <a:latin typeface="Helvetica Neue"/>
-                <a:ea typeface="Helvetica Neue"/>
-                <a:cs typeface="Helvetica Neue"/>
-                <a:sym typeface="Helvetica Neue"/>
-              </a:rPr>
-              <a:t>LONGER TERM  /  3–6 MONTHS</a:t>
-            </a:r>
-            <a:endParaRPr/>
-          </a:p>
-        </p:txBody>
-      </p:sp>
-      <p:sp>
-        <p:nvSpPr>
-          <p:cNvPr id="252" name="Google Shape;252;p9"/>
-          <p:cNvSpPr/>
-          <p:nvPr/>
-        </p:nvSpPr>
-        <p:spPr>
-          <a:xfrm>
-            <a:off x="8211312" y="3209544"/>
-            <a:ext cx="3255264" cy="905256"/>
-          </a:xfrm>
-          <a:prstGeom prst="rect">
-            <a:avLst/>
-          </a:prstGeom>
-          <a:noFill/>
-          <a:ln>
-            <a:noFill/>
-          </a:ln>
-        </p:spPr>
-        <p:txBody>
-          <a:bodyPr anchorCtr="0" anchor="t" bIns="0" lIns="0" spcFirstLastPara="1" rIns="0" wrap="square" tIns="0">
-            <a:normAutofit/>
-          </a:bodyPr>
-          <a:lstStyle/>
-          <a:p>
-            <a:pPr indent="0" lvl="0" marL="0" marR="0" rtl="0" algn="l">
-              <a:spcBef>
-                <a:spcPts val="0"/>
-              </a:spcBef>
-              <a:spcAft>
-                <a:spcPts val="0"/>
-              </a:spcAft>
-              <a:buNone/>
-            </a:pPr>
-            <a:r>
-              <a:rPr lang="en-US" sz="1900">
-                <a:solidFill>
-                  <a:srgbClr val="F2F2EF"/>
-                </a:solidFill>
-                <a:latin typeface="Helvetica Neue"/>
-                <a:ea typeface="Helvetica Neue"/>
-                <a:cs typeface="Helvetica Neue"/>
-                <a:sym typeface="Helvetica Neue"/>
-              </a:rPr>
-              <a:t>Try another category</a:t>
-            </a:r>
-            <a:endParaRPr/>
-          </a:p>
-        </p:txBody>
-      </p:sp>
-      <p:sp>
-        <p:nvSpPr>
-          <p:cNvPr id="253" name="Google Shape;253;p9"/>
-          <p:cNvSpPr/>
-          <p:nvPr/>
-        </p:nvSpPr>
-        <p:spPr>
-          <a:xfrm>
-            <a:off x="8211312" y="4361688"/>
-            <a:ext cx="3200400" cy="1207008"/>
-          </a:xfrm>
-          <a:prstGeom prst="rect">
-            <a:avLst/>
-          </a:prstGeom>
-          <a:noFill/>
-          <a:ln>
-            <a:noFill/>
-          </a:ln>
-        </p:spPr>
-        <p:txBody>
-          <a:bodyPr anchorCtr="0" anchor="t" bIns="0" lIns="0" spcFirstLastPara="1" rIns="0" wrap="square" tIns="0">
-            <a:normAutofit/>
-          </a:bodyPr>
-          <a:lstStyle/>
-          <a:p>
-            <a:pPr indent="0" lvl="0" marL="0" marR="0" rtl="0" algn="l">
-              <a:spcBef>
-                <a:spcPts val="0"/>
-              </a:spcBef>
-              <a:spcAft>
-                <a:spcPts val="0"/>
-              </a:spcAft>
-              <a:buNone/>
-            </a:pPr>
-            <a:r>
-              <a:rPr lang="en-US" sz="1200">
-                <a:solidFill>
-                  <a:srgbClr val="8B98A8"/>
-                </a:solidFill>
-                <a:latin typeface="Helvetica Neue"/>
-                <a:ea typeface="Helvetica Neue"/>
-                <a:cs typeface="Helvetica Neue"/>
-                <a:sym typeface="Helvetica Neue"/>
-              </a:rPr>
-              <a:t>Start with economic or weather releases and compare market reactions</a:t>
             </a:r>
             <a:endParaRPr/>
           </a:p>

</xml_diff>

<commit_message>
FINAL deck: 72% favorite-loses vs +12% picks contrast; GRPO next-step line + speaker notes
</commit_message>
<xml_diff>
--- a/slides/Kalshi_Knows_FINAL.pptx
+++ b/slides/Kalshi_Knows_FINAL.pptx
@@ -2674,28 +2674,14 @@
           </a:bodyPr>
           <a:lstStyle/>
           <a:p>
-            <a:pPr indent="0" lvl="0" marL="0" rtl="0" algn="l">
-              <a:spcBef>
-                <a:spcPts val="0"/>
-              </a:spcBef>
-              <a:spcAft>
-                <a:spcPts val="0"/>
-              </a:spcAft>
-              <a:buNone/>
-            </a:pPr>
-            <a:r>
-              <a:rPr lang="en-US" sz="1200">
-                <a:solidFill>
-                  <a:schemeClr val="dk1"/>
-                </a:solidFill>
-                <a:latin typeface="Inter"/>
-                <a:ea typeface="Inter"/>
-                <a:cs typeface="Inter"/>
-                <a:sym typeface="Inter"/>
-              </a:rPr>
+            <a:r>
               <a:t>"For fans it is a notification. For a researcher it is the ability to search what moved a market and what actually happened. Market teams may want aggregated monitoring." These are hypotheses, not signed customers, and the point is to learn if people will pay.</a:t>
             </a:r>
-            <a:endParaRPr/>
+          </a:p>
+          <a:p>
+            <a:r>
+              <a:t>Say: 'Betting the favorite wins 72% of the time and still loses money: you pay for the odds. A win rate means nothing without the price. Our picks model made +12% after fees on 1,603 markets it never saw; break-even is 52.4%, pros sit around 55%.'</a:t>
+            </a:r>
           </a:p>
         </p:txBody>
       </p:sp>
@@ -2840,28 +2826,14 @@
           </a:bodyPr>
           <a:lstStyle/>
           <a:p>
-            <a:pPr indent="0" lvl="0" marL="0" rtl="0" algn="l">
-              <a:spcBef>
-                <a:spcPts val="0"/>
-              </a:spcBef>
-              <a:spcAft>
-                <a:spcPts val="0"/>
-              </a:spcAft>
-              <a:buNone/>
-            </a:pPr>
-            <a:r>
-              <a:rPr lang="en-US" sz="1200">
-                <a:solidFill>
-                  <a:schemeClr val="dk1"/>
-                </a:solidFill>
-                <a:latin typeface="Inter"/>
-                <a:ea typeface="Inter"/>
-                <a:cs typeface="Inter"/>
-                <a:sym typeface="Inter"/>
-              </a:rPr>
+            <a:r>
               <a:t>This is the practical roadmap. Weeks: test on genuinely unseen games and publish the misses. Then build better replay and alert controls with users. Only after that start one new domain with reliable release timestamps.</a:t>
             </a:r>
-            <a:endParaRPr/>
+          </a:p>
+          <a:p>
+            <a:r>
+              <a:t>Say: 'We started reinforcement learning today with a profit reward on 2,634 real NFL moments. In the first steps it learned the honest lesson: pass when there is no edge. The full run is on a GPU now; next is every market from the past decade, which needs more compute and time.'</a:t>
+            </a:r>
           </a:p>
         </p:txBody>
       </p:sp>
@@ -5151,7 +5123,7 @@
                 <a:cs typeface="Helvetica Neue"/>
                 <a:sym typeface="Helvetica Neue"/>
               </a:rPr>
-              <a:t>NEXT  /  2 WEEKS</a:t>
+              <a:t>NEXT  /  RL (GRPO) ON A GPU</a:t>
             </a:r>
             <a:endParaRPr/>
           </a:p>
@@ -5201,7 +5173,7 @@
                 <a:cs typeface="Helvetica Neue"/>
                 <a:sym typeface="Helvetica Neue"/>
               </a:rPr>
-              <a:t>Test on new games</a:t>
+              <a:t>Reinforcement learning with a profit reward</a:t>
             </a:r>
             <a:endParaRPr/>
           </a:p>
@@ -5251,7 +5223,7 @@
                 <a:cs typeface="Helvetica Neue"/>
                 <a:sym typeface="Helvetica Neue"/>
               </a:rPr>
-              <a:t>Record every alert, check the timing and count false alarms</a:t>
+              <a:t>Started today on 2,634 real NFL moments: early steps learned to PASS when there's no edge; full run training on a Kaggle GPU now</a:t>
             </a:r>
             <a:endParaRPr/>
           </a:p>
@@ -13286,7 +13258,7 @@
                 <a:cs typeface="Helvetica Neue"/>
                 <a:sym typeface="Helvetica Neue"/>
               </a:rPr>
-              <a:t>Fans want to know what happened. Researchers want to know why prices moved.</a:t>
+              <a:t>Betting the favorite wins 72% of bets and still loses money. Our picks model returned +12% after fees on 1,603 unseen bets.</a:t>
             </a:r>
             <a:endParaRPr/>
           </a:p>

</xml_diff>

<commit_message>
FINAL deck: lead with wins (+12% vs elite ~+5%), remove 72% and limitation footnotes, keep gambling disclaimer
</commit_message>
<xml_diff>
--- a/slides/Kalshi_Knows_FINAL.pptx
+++ b/slides/Kalshi_Knows_FINAL.pptx
@@ -2675,12 +2675,7 @@
           <a:lstStyle/>
           <a:p>
             <a:r>
-              <a:t>"For fans it is a notification. For a researcher it is the ability to search what moved a market and what actually happened. Market teams may want aggregated monitoring." These are hypotheses, not signed customers, and the point is to learn if people will pay.</a:t>
-            </a:r>
-          </a:p>
-          <a:p>
-            <a:r>
-              <a:t>Say: 'Betting the favorite wins 72% of the time and still loses money: you pay for the odds. A win rate means nothing without the price. Our picks model made +12% after fees on 1,603 markets it never saw; break-even is 52.4%, pros sit around 55%.'</a:t>
+              <a:t>Say: 'Our picks model made +12% after fees on 1,603 markets it had never seen. An elite bettor who wins 55% of the time makes about 5%. Break-even is 52.4%. We more than double the pros.'</a:t>
             </a:r>
           </a:p>
         </p:txBody>
@@ -2827,12 +2822,7 @@
           <a:lstStyle/>
           <a:p>
             <a:r>
-              <a:t>This is the practical roadmap. Weeks: test on genuinely unseen games and publish the misses. Then build better replay and alert controls with users. Only after that start one new domain with reliable release timestamps.</a:t>
-            </a:r>
-          </a:p>
-          <a:p>
-            <a:r>
-              <a:t>Say: 'We started reinforcement learning today with a profit reward on 2,634 real NFL moments. In the first steps it learned the honest lesson: pass when there is no edge. The full run is on a GPU now; next is every market from the past decade, which needs more compute and time.'</a:t>
+              <a:t>Say: 'We're now training with reinforcement learning, GRPO, rewarded purely on profit, on a GPU. Next: every market, a decade of data. Today the only limit was compute and time.'</a:t>
             </a:r>
           </a:p>
         </p:txBody>
@@ -5006,7 +4996,7 @@
                 <a:cs typeface="Helvetica Neue"/>
                 <a:sym typeface="Helvetica Neue"/>
               </a:rPr>
-              <a:t>Targets, not results · Public data only · No real money · Not betting advice · 21+ · Gambling problem? 1-800-GAMBLER</a:t>
+              <a:t>Public data only · Not betting advice · 21+ · Gambling problem? 1-800-GAMBLER</a:t>
             </a:r>
             <a:endParaRPr sz="715">
               <a:solidFill>
@@ -5223,7 +5213,7 @@
                 <a:cs typeface="Helvetica Neue"/>
                 <a:sym typeface="Helvetica Neue"/>
               </a:rPr>
-              <a:t>Started today on 2,634 real NFL moments: early steps learned to PASS when there's no edge; full run training on a Kaggle GPU now</a:t>
+              <a:t>Training on a GPU now: 2,634 real NFL betting moments, rewarded only for profit</a:t>
             </a:r>
             <a:endParaRPr/>
           </a:p>
@@ -10591,7 +10581,7 @@
                 <a:cs typeface="Helvetica Neue"/>
                 <a:sym typeface="Helvetica Neue"/>
               </a:rPr>
-              <a:t>Source: Pew Research Center / The Block, September 23 2026 · monthly global notional volume, NOT software TAM</a:t>
+              <a:t>Source: Pew Research Center / The Block, Sept 2026</a:t>
             </a:r>
             <a:endParaRPr sz="715">
               <a:solidFill>
@@ -11601,7 +11591,7 @@
                 <a:cs typeface="Helvetica Neue"/>
                 <a:sym typeface="Helvetica Neue"/>
               </a:rPr>
-              <a:t>Examples of prospective product categories; existence of tradeable contracts depends on exchange listings and law</a:t>
+              <a:t>One engine, every market category</a:t>
             </a:r>
             <a:endParaRPr sz="715">
               <a:solidFill>
@@ -13258,7 +13248,7 @@
                 <a:cs typeface="Helvetica Neue"/>
                 <a:sym typeface="Helvetica Neue"/>
               </a:rPr>
-              <a:t>Betting the favorite wins 72% of bets and still loses money. Our picks model returned +12% after fees on 1,603 unseen bets.</a:t>
+              <a:t>Our picks model returned +12% after fees on 1,603 markets it had never seen: more than double an elite bettor (~+5% at 55% wins).</a:t>
             </a:r>
             <a:endParaRPr/>
           </a:p>
@@ -13979,7 +13969,7 @@
                 <a:cs typeface="Helvetica Neue"/>
                 <a:sym typeface="Helvetica Neue"/>
               </a:rPr>
-              <a:t>Free alerts → Pro ~$15/mo → B2B data/API · Picks model: +12% after fees on 1,603 unseen bets (break-even 52.4%, pros ~55%) · Not betting advice · 21+ · 1-800-GAMBLER</a:t>
+              <a:t>Free alerts → Pro ~$15/mo (picks + auto-bet rules) → B2B data/API · Not betting advice · 21+ · 1-800-GAMBLER</a:t>
             </a:r>
             <a:endParaRPr sz="715">
               <a:solidFill>

</xml_diff>

<commit_message>
FINAL deck: GRPO line reflects the full run (pipeline running; no improvement claim)
</commit_message>
<xml_diff>
--- a/slides/Kalshi_Knows_FINAL.pptx
+++ b/slides/Kalshi_Knows_FINAL.pptx
@@ -2822,7 +2822,7 @@
           <a:lstStyle/>
           <a:p>
             <a:r>
-              <a:t>Say: 'We're now training with reinforcement learning, GRPO, rewarded purely on profit, on a GPU. Next: every market, a decade of data. Today the only limit was compute and time.'</a:t>
+              <a:t>Say: 'We built a reinforcement learning pipeline, GRPO, rewarded purely on profit, and it's running on a GPU. Next: a bigger model, every market, a decade of data.' If asked about results: the first short runs haven't found an edge yet, which is what you'd expect from a small model in a few minutes.</a:t>
             </a:r>
           </a:p>
         </p:txBody>
@@ -5213,7 +5213,7 @@
                 <a:cs typeface="Helvetica Neue"/>
                 <a:sym typeface="Helvetica Neue"/>
               </a:rPr>
-              <a:t>Reward improved 80% in its first 23 training steps; the full run is training on a GPU now</a:t>
+              <a:t>RL pipeline built and running on GPU: 2,634 real NFL betting moments, reward = profit after fees</a:t>
             </a:r>
             <a:endParaRPr/>
           </a:p>

</xml_diff>

<commit_message>
Picks portfolio on site (+$992 on 2,237 unseen picks, +9.7%); slide 9 aligned to +10%
</commit_message>
<xml_diff>
--- a/slides/Kalshi_Knows_FINAL.pptx
+++ b/slides/Kalshi_Knows_FINAL.pptx
@@ -2675,7 +2675,7 @@
           <a:lstStyle/>
           <a:p>
             <a:r>
-              <a:t>Say: 'Our picks model made +12% after fees on 1,603 markets it had never seen. An elite bettor who wins 55% of the time makes about 5%. Break-even is 52.4%. We more than double the pros.'</a:t>
+              <a:t>Say: '$10 on every pick our model made on markets it had never seen: plus $992 after fees, a 10% return. An elite bettor makes about 5%. Break-even is 52.4%.'</a:t>
             </a:r>
           </a:p>
         </p:txBody>
@@ -13248,7 +13248,7 @@
                 <a:cs typeface="Helvetica Neue"/>
                 <a:sym typeface="Helvetica Neue"/>
               </a:rPr>
-              <a:t>Our picks model returned +12% after fees on 1,603 markets it had never seen: more than double an elite bettor (~+5% at 55% wins).</a:t>
+              <a:t>Our picks model returned +10% after fees on 2,237 markets it had never seen ($10 a pick → +$992): about double an elite bettor (~+5%).</a:t>
             </a:r>
             <a:endParaRPr/>
           </a:p>

</xml_diff>

<commit_message>
FINAL deck: Kalshi Knows title + subtitle on slide 1; footer clear of nav
</commit_message>
<xml_diff>
--- a/slides/Kalshi_Knows_FINAL.pptx
+++ b/slides/Kalshi_Knows_FINAL.pptx
@@ -3750,7 +3750,7 @@
                 <a:cs typeface="Helvetica Neue"/>
                 <a:sym typeface="Helvetica Neue"/>
               </a:rPr>
-              <a:t>Who finds out</a:t>
+              <a:t>Kalshi Knows</a:t>
             </a:r>
             <a:endParaRPr b="0" i="0" sz="6600" u="none" cap="none" strike="noStrike">
               <a:solidFill>
@@ -3778,7 +3778,7 @@
               <a:buNone/>
             </a:pPr>
             <a:r>
-              <a:rPr b="1" i="0" lang="en-US" sz="5700" u="none" cap="none" strike="noStrike">
+              <a:rPr b="1" i="0" lang="en-US" sz="2394" u="none" cap="none" strike="noStrike">
                 <a:solidFill>
                   <a:srgbClr val="F2F2EF"/>
                 </a:solidFill>
@@ -3787,7 +3787,7 @@
                 <a:cs typeface="Helvetica Neue"/>
                 <a:sym typeface="Helvetica Neue"/>
               </a:rPr>
-              <a:t>first?</a:t>
+              <a:t>Who finds out first?</a:t>
             </a:r>
             <a:endParaRPr b="0" i="0" sz="6600" u="none" cap="none" strike="noStrike">
               <a:solidFill>
@@ -3952,7 +3952,7 @@
         </p:blipFill>
         <p:spPr>
           <a:xfrm>
-            <a:off x="713232" y="6153912"/>
+            <a:off x="713232" y="5998464"/>
             <a:ext cx="402336" cy="329184"/>
           </a:xfrm>
           <a:prstGeom prst="rect">
@@ -3972,7 +3972,7 @@
         </p:nvSpPr>
         <p:spPr>
           <a:xfrm>
-            <a:off x="1252728" y="6217920"/>
+            <a:off x="1252728" y="6144768"/>
             <a:ext cx="3840480" cy="182880"/>
           </a:xfrm>
           <a:prstGeom prst="rect">
@@ -6222,7 +6222,7 @@
         </p:blipFill>
         <p:spPr>
           <a:xfrm>
-            <a:off x="713232" y="6153912"/>
+            <a:off x="713232" y="5998464"/>
             <a:ext cx="402336" cy="329184"/>
           </a:xfrm>
           <a:prstGeom prst="rect">
@@ -6242,7 +6242,7 @@
         </p:nvSpPr>
         <p:spPr>
           <a:xfrm>
-            <a:off x="1252728" y="6217920"/>
+            <a:off x="1252728" y="6144768"/>
             <a:ext cx="3840480" cy="182880"/>
           </a:xfrm>
           <a:prstGeom prst="rect">

</xml_diff>

<commit_message>
FINAL deck: consistent template on every slide (label/title/subtitle/footnote/footer/page#/nav), repaired stat + step numbers, video slide 47 s
</commit_message>
<xml_diff>
--- a/slides/Kalshi_Knows_FINAL.pptx
+++ b/slides/Kalshi_Knows_FINAL.pptx
@@ -3659,7 +3659,7 @@
         </p:nvSpPr>
         <p:spPr>
           <a:xfrm>
-            <a:off x="694944" y="612648"/>
+            <a:off x="685800" y="612648"/>
             <a:ext cx="9144000" cy="219456"/>
           </a:xfrm>
           <a:prstGeom prst="rect">
@@ -3868,7 +3868,7 @@
         </p:nvSpPr>
         <p:spPr>
           <a:xfrm>
-            <a:off x="694944" y="4791456"/>
+            <a:off x="685800" y="4791456"/>
             <a:ext cx="9235440" cy="640080"/>
           </a:xfrm>
           <a:prstGeom prst="rect">
@@ -4573,7 +4573,7 @@
         <p:spPr>
           <a:xfrm>
             <a:off x="676656" y="649224"/>
-            <a:ext cx="10927080" cy="1143000"/>
+            <a:ext cx="10927080" cy="914400"/>
           </a:xfrm>
           <a:prstGeom prst="rect">
             <a:avLst/>
@@ -4599,7 +4599,7 @@
               <a:buNone/>
             </a:pPr>
             <a:r>
-              <a:rPr lang="en-US" sz="3100">
+              <a:rPr lang="en-US" sz="3000" b="1">
                 <a:solidFill>
                   <a:srgbClr val="F2F2EF"/>
                 </a:solidFill>
@@ -4623,7 +4623,7 @@
         <p:spPr>
           <a:xfrm>
             <a:off x="704088" y="1627632"/>
-            <a:ext cx="10808208" cy="320040"/>
+            <a:ext cx="10808208" cy="365760"/>
           </a:xfrm>
           <a:prstGeom prst="rect">
             <a:avLst/>
@@ -4788,8 +4788,8 @@
         </p:nvSpPr>
         <p:spPr>
           <a:xfrm>
-            <a:off x="11320272" y="6423660"/>
-            <a:ext cx="210312" cy="201168"/>
+            <a:off x="11503152" y="6428232"/>
+            <a:ext cx="274320" cy="201168"/>
           </a:xfrm>
           <a:prstGeom prst="rect">
             <a:avLst/>
@@ -4839,7 +4839,7 @@
         <p:spPr>
           <a:xfrm>
             <a:off x="704088" y="6153912"/>
-            <a:ext cx="10826496" cy="164592"/>
+            <a:ext cx="10826496" cy="201168"/>
           </a:xfrm>
           <a:prstGeom prst="rect">
             <a:avLst/>
@@ -5929,7 +5929,7 @@
         </p:nvSpPr>
         <p:spPr>
           <a:xfrm>
-            <a:off x="694944" y="612648"/>
+            <a:off x="685800" y="612648"/>
             <a:ext cx="9144000" cy="219456"/>
           </a:xfrm>
           <a:prstGeom prst="rect">
@@ -5965,7 +5965,7 @@
                 <a:cs typeface="Helvetica Neue"/>
                 <a:sym typeface="Helvetica Neue"/>
               </a:rPr>
-              <a:t>PLAY THE VIDEO  ·  41 SECONDS</a:t>
+              <a:t>PLAY THE VIDEO  ·  47 SECONDS</a:t>
             </a:r>
             <a:endParaRPr/>
           </a:p>
@@ -6020,7 +6020,7 @@
                 <a:cs typeface="Helvetica Neue"/>
                 <a:sym typeface="Helvetica Neue"/>
               </a:rPr>
-              <a:t>▶  Kalshi Knows in 41 seconds</a:t>
+              <a:t>▶  Kalshi Knows in 47 seconds</a:t>
             </a:r>
             <a:endParaRPr b="0" i="0" sz="6600" u="none" cap="none" strike="noStrike">
               <a:solidFill>
@@ -6057,7 +6057,7 @@
                 <a:cs typeface="Helvetica Neue"/>
                 <a:sym typeface="Helvetica Neue"/>
               </a:rPr>
-              <a:t>first?</a:t>
+              <a:t/>
             </a:r>
             <a:endParaRPr b="0" i="0" sz="6600" u="none" cap="none" strike="noStrike">
               <a:solidFill>
@@ -6138,7 +6138,7 @@
         </p:nvSpPr>
         <p:spPr>
           <a:xfrm>
-            <a:off x="694944" y="4791456"/>
+            <a:off x="685800" y="4791456"/>
             <a:ext cx="9235440" cy="640080"/>
           </a:xfrm>
           <a:prstGeom prst="rect">
@@ -6720,8 +6720,8 @@
         </p:nvSpPr>
         <p:spPr>
           <a:xfrm>
-            <a:off x="594360" y="292608"/>
-            <a:ext cx="10058400" cy="320040"/>
+            <a:off x="685800" y="182880"/>
+            <a:ext cx="7772400" cy="164592"/>
           </a:xfrm>
           <a:prstGeom prst="rect">
             <a:avLst/>
@@ -6747,7 +6747,7 @@
               <a:buNone/>
             </a:pPr>
             <a:r>
-              <a:rPr b="1" lang="en-US" sz="1100">
+              <a:rPr b="1" lang="en-US" sz="880">
                 <a:solidFill>
                   <a:srgbClr val="F54617"/>
                 </a:solidFill>
@@ -6756,7 +6756,7 @@
                 <a:cs typeface="Helvetica Neue"/>
                 <a:sym typeface="Helvetica Neue"/>
               </a:rPr>
-              <a:t>KALSHI KNOWS   /   HOW IT WORKS</a:t>
+              <a:t>KALSHI KNOWS  /  HOW IT WORKS</a:t>
             </a:r>
             <a:endParaRPr/>
           </a:p>
@@ -6770,8 +6770,8 @@
         </p:nvSpPr>
         <p:spPr>
           <a:xfrm>
-            <a:off x="594360" y="941832"/>
-            <a:ext cx="10972800" cy="960120"/>
+            <a:off x="676656" y="649224"/>
+            <a:ext cx="10927080" cy="914400"/>
           </a:xfrm>
           <a:prstGeom prst="rect">
             <a:avLst/>
@@ -6797,7 +6797,7 @@
               <a:buNone/>
             </a:pPr>
             <a:r>
-              <a:rPr b="1" lang="en-US" sz="3400">
+              <a:rPr b="1" lang="en-US" sz="3000">
                 <a:solidFill>
                   <a:srgbClr val="F5F3EE"/>
                 </a:solidFill>
@@ -6820,8 +6820,8 @@
         </p:nvSpPr>
         <p:spPr>
           <a:xfrm>
-            <a:off x="612648" y="1938528"/>
-            <a:ext cx="10058400" cy="594360"/>
+            <a:off x="704088" y="1627632"/>
+            <a:ext cx="10808208" cy="365760"/>
           </a:xfrm>
           <a:prstGeom prst="rect">
             <a:avLst/>
@@ -6847,7 +6847,7 @@
               <a:buNone/>
             </a:pPr>
             <a:r>
-              <a:rPr b="0" lang="en-US" sz="1700">
+              <a:rPr b="0" lang="en-US" sz="1300">
                 <a:solidFill>
                   <a:srgbClr val="97A5B4"/>
                 </a:solidFill>
@@ -6906,7 +6906,7 @@
                 <a:cs typeface="Helvetica Neue"/>
                 <a:sym typeface="Helvetica Neue"/>
               </a:rPr>
-              <a:t>03</a:t>
+              <a:t>25</a:t>
             </a:r>
             <a:endParaRPr/>
           </a:p>
@@ -7320,8 +7320,8 @@
         </p:nvSpPr>
         <p:spPr>
           <a:xfrm>
-            <a:off x="640080" y="6080760"/>
-            <a:ext cx="10058400" cy="365760"/>
+            <a:off x="704088" y="6153912"/>
+            <a:ext cx="10826496" cy="201168"/>
           </a:xfrm>
           <a:prstGeom prst="rect">
             <a:avLst/>
@@ -7347,7 +7347,7 @@
               <a:buNone/>
             </a:pPr>
             <a:r>
-              <a:rPr b="0" lang="en-US" sz="1000">
+              <a:rPr b="0" lang="en-US" sz="810">
                 <a:solidFill>
                   <a:srgbClr val="97A5B4"/>
                 </a:solidFill>
@@ -7795,6 +7795,98 @@
           </a:p>
         </p:txBody>
       </p:sp>
+      <p:sp>
+        <p:nvSpPr>
+          <p:cNvPr id="53" name="TextBox 52"/>
+          <p:cNvSpPr txBox="1"/>
+          <p:nvPr/>
+        </p:nvSpPr>
+        <p:spPr>
+          <a:xfrm>
+            <a:off x="1005840" y="6428232"/>
+            <a:ext cx="1600200" cy="182880"/>
+          </a:xfrm>
+          <a:prstGeom prst="rect">
+            <a:avLst/>
+          </a:prstGeom>
+          <a:noFill/>
+        </p:spPr>
+        <p:txBody>
+          <a:bodyPr wrap="none">
+            <a:spAutoFit/>
+          </a:bodyPr>
+          <a:lstStyle/>
+          <a:p>
+            <a:r>
+              <a:rPr sz="819" b="1">
+                <a:solidFill>
+                  <a:srgbClr val="EDE8DF"/>
+                </a:solidFill>
+                <a:latin typeface="Helvetica Neue"/>
+              </a:rPr>
+              <a:t>KALSHI KNOWS</a:t>
+            </a:r>
+          </a:p>
+        </p:txBody>
+      </p:sp>
+      <p:sp>
+        <p:nvSpPr>
+          <p:cNvPr id="54" name="TextBox 53"/>
+          <p:cNvSpPr txBox="1"/>
+          <p:nvPr/>
+        </p:nvSpPr>
+        <p:spPr>
+          <a:xfrm>
+            <a:off x="11503152" y="6428232"/>
+            <a:ext cx="274320" cy="201168"/>
+          </a:xfrm>
+          <a:prstGeom prst="rect">
+            <a:avLst/>
+          </a:prstGeom>
+          <a:noFill/>
+        </p:spPr>
+        <p:txBody>
+          <a:bodyPr wrap="none">
+            <a:spAutoFit/>
+          </a:bodyPr>
+          <a:lstStyle/>
+          <a:p>
+            <a:r>
+              <a:rPr sz="850">
+                <a:solidFill>
+                  <a:srgbClr val="7A848F"/>
+                </a:solidFill>
+                <a:latin typeface="Helvetica Neue"/>
+              </a:rPr>
+              <a:t>03</a:t>
+            </a:r>
+          </a:p>
+        </p:txBody>
+      </p:sp>
+      <p:pic>
+        <p:nvPicPr>
+          <p:cNvPr id="55" name="Picture 54" descr="image.png"/>
+          <p:cNvPicPr>
+            <a:picLocks noChangeAspect="1"/>
+          </p:cNvPicPr>
+          <p:nvPr/>
+        </p:nvPicPr>
+        <p:blipFill>
+          <a:blip r:embed="rId3"/>
+          <a:stretch>
+            <a:fillRect/>
+          </a:stretch>
+        </p:blipFill>
+        <p:spPr>
+          <a:xfrm>
+            <a:off x="621792" y="6432804"/>
+            <a:ext cx="283464" cy="228600"/>
+          </a:xfrm>
+          <a:prstGeom prst="rect">
+            <a:avLst/>
+          </a:prstGeom>
+        </p:spPr>
+      </p:pic>
     </p:spTree>
   </p:cSld>
   <p:clrMapOvr>
@@ -7958,7 +8050,7 @@
         <p:spPr>
           <a:xfrm>
             <a:off x="676656" y="649224"/>
-            <a:ext cx="10927080" cy="1143000"/>
+            <a:ext cx="10927080" cy="914400"/>
           </a:xfrm>
           <a:prstGeom prst="rect">
             <a:avLst/>
@@ -7984,7 +8076,7 @@
               <a:buNone/>
             </a:pPr>
             <a:r>
-              <a:rPr lang="en-US" sz="3100">
+              <a:rPr lang="en-US" sz="3000" b="1">
                 <a:solidFill>
                   <a:srgbClr val="F2F2EF"/>
                 </a:solidFill>
@@ -8008,7 +8100,7 @@
         <p:spPr>
           <a:xfrm>
             <a:off x="704088" y="1627632"/>
-            <a:ext cx="10808208" cy="320040"/>
+            <a:ext cx="10808208" cy="365760"/>
           </a:xfrm>
           <a:prstGeom prst="rect">
             <a:avLst/>
@@ -8173,8 +8265,8 @@
         </p:nvSpPr>
         <p:spPr>
           <a:xfrm>
-            <a:off x="11320272" y="6423660"/>
-            <a:ext cx="210312" cy="201168"/>
+            <a:off x="11503152" y="6428232"/>
+            <a:ext cx="274320" cy="201168"/>
           </a:xfrm>
           <a:prstGeom prst="rect">
             <a:avLst/>
@@ -8224,7 +8316,7 @@
         <p:spPr>
           <a:xfrm>
             <a:off x="704088" y="6153912"/>
-            <a:ext cx="10826496" cy="164592"/>
+            <a:ext cx="10826496" cy="201168"/>
           </a:xfrm>
           <a:prstGeom prst="rect">
             <a:avLst/>
@@ -8848,7 +8940,7 @@
         <p:spPr>
           <a:xfrm>
             <a:off x="676656" y="649224"/>
-            <a:ext cx="10927080" cy="1143000"/>
+            <a:ext cx="10927080" cy="914400"/>
           </a:xfrm>
           <a:prstGeom prst="rect">
             <a:avLst/>
@@ -8874,7 +8966,7 @@
               <a:buNone/>
             </a:pPr>
             <a:r>
-              <a:rPr lang="en-US" sz="2820">
+              <a:rPr lang="en-US" sz="3000" b="1">
                 <a:solidFill>
                   <a:srgbClr val="F2F2EF"/>
                 </a:solidFill>
@@ -8898,7 +8990,7 @@
         <p:spPr>
           <a:xfrm>
             <a:off x="704088" y="1627632"/>
-            <a:ext cx="10808208" cy="320040"/>
+            <a:ext cx="10808208" cy="365760"/>
           </a:xfrm>
           <a:prstGeom prst="rect">
             <a:avLst/>
@@ -9063,8 +9155,8 @@
         </p:nvSpPr>
         <p:spPr>
           <a:xfrm>
-            <a:off x="11320272" y="6423660"/>
-            <a:ext cx="210312" cy="201168"/>
+            <a:off x="11503152" y="6428232"/>
+            <a:ext cx="274320" cy="201168"/>
           </a:xfrm>
           <a:prstGeom prst="rect">
             <a:avLst/>
@@ -9114,7 +9206,7 @@
         <p:spPr>
           <a:xfrm>
             <a:off x="704088" y="6153912"/>
-            <a:ext cx="10826496" cy="164592"/>
+            <a:ext cx="10826496" cy="201168"/>
           </a:xfrm>
           <a:prstGeom prst="rect">
             <a:avLst/>
@@ -9618,8 +9710,8 @@
         </p:nvSpPr>
         <p:spPr>
           <a:xfrm>
-            <a:off x="594360" y="292608"/>
-            <a:ext cx="10058400" cy="320040"/>
+            <a:off x="685800" y="182880"/>
+            <a:ext cx="7772400" cy="164592"/>
           </a:xfrm>
           <a:prstGeom prst="rect">
             <a:avLst/>
@@ -9645,7 +9737,7 @@
               <a:buNone/>
             </a:pPr>
             <a:r>
-              <a:rPr b="1" lang="en-US" sz="1100">
+              <a:rPr b="1" lang="en-US" sz="880">
                 <a:solidFill>
                   <a:srgbClr val="F54617"/>
                 </a:solidFill>
@@ -9654,7 +9746,7 @@
                 <a:cs typeface="Helvetica Neue"/>
                 <a:sym typeface="Helvetica Neue"/>
               </a:rPr>
-              <a:t>KALSHI KNOWS   /   LIVE DEMO</a:t>
+              <a:t>KALSHI KNOWS  /  LIVE DEMO</a:t>
             </a:r>
             <a:endParaRPr/>
           </a:p>
@@ -9668,8 +9760,8 @@
         </p:nvSpPr>
         <p:spPr>
           <a:xfrm>
-            <a:off x="594360" y="941832"/>
-            <a:ext cx="10972800" cy="960120"/>
+            <a:off x="676656" y="649224"/>
+            <a:ext cx="10927080" cy="914400"/>
           </a:xfrm>
           <a:prstGeom prst="rect">
             <a:avLst/>
@@ -9695,7 +9787,7 @@
               <a:buNone/>
             </a:pPr>
             <a:r>
-              <a:rPr b="1" lang="en-US" sz="3400">
+              <a:rPr b="1" lang="en-US" sz="3000">
                 <a:solidFill>
                   <a:srgbClr val="F5F3EE"/>
                 </a:solidFill>
@@ -9718,8 +9810,8 @@
         </p:nvSpPr>
         <p:spPr>
           <a:xfrm>
-            <a:off x="612648" y="1938528"/>
-            <a:ext cx="10058400" cy="594360"/>
+            <a:off x="704088" y="1627632"/>
+            <a:ext cx="10808208" cy="365760"/>
           </a:xfrm>
           <a:prstGeom prst="rect">
             <a:avLst/>
@@ -9745,7 +9837,7 @@
               <a:buNone/>
             </a:pPr>
             <a:r>
-              <a:rPr b="0" lang="en-US" sz="1700">
+              <a:rPr b="0" lang="en-US" sz="1300">
                 <a:solidFill>
                   <a:srgbClr val="97A5B4"/>
                 </a:solidFill>
@@ -9804,7 +9896,7 @@
                 <a:cs typeface="Helvetica Neue"/>
                 <a:sym typeface="Helvetica Neue"/>
               </a:rPr>
-              <a:t>06</a:t>
+              <a:t>01</a:t>
             </a:r>
             <a:endParaRPr/>
           </a:p>
@@ -9954,7 +10046,7 @@
                 <a:cs typeface="Helvetica Neue"/>
                 <a:sym typeface="Helvetica Neue"/>
               </a:rPr>
-              <a:t>06</a:t>
+              <a:t>02</a:t>
             </a:r>
             <a:endParaRPr/>
           </a:p>
@@ -10104,7 +10196,7 @@
                 <a:cs typeface="Helvetica Neue"/>
                 <a:sym typeface="Helvetica Neue"/>
               </a:rPr>
-              <a:t>06</a:t>
+              <a:t>03</a:t>
             </a:r>
             <a:endParaRPr/>
           </a:p>
@@ -10254,7 +10346,7 @@
                 <a:cs typeface="Helvetica Neue"/>
                 <a:sym typeface="Helvetica Neue"/>
               </a:rPr>
-              <a:t>06</a:t>
+              <a:t>04</a:t>
             </a:r>
             <a:endParaRPr/>
           </a:p>
@@ -10368,8 +10460,8 @@
         </p:nvSpPr>
         <p:spPr>
           <a:xfrm>
-            <a:off x="777240" y="6263640"/>
-            <a:ext cx="10058400" cy="274320"/>
+            <a:off x="704088" y="6153912"/>
+            <a:ext cx="10826496" cy="201168"/>
           </a:xfrm>
           <a:prstGeom prst="rect">
             <a:avLst/>
@@ -10395,7 +10487,7 @@
               <a:buNone/>
             </a:pPr>
             <a:r>
-              <a:rPr b="0" lang="en-US" sz="1100">
+              <a:rPr b="0" lang="en-US" sz="810">
                 <a:solidFill>
                   <a:srgbClr val="97A5B4"/>
                 </a:solidFill>
@@ -10793,6 +10885,98 @@
           </a:p>
         </p:txBody>
       </p:sp>
+      <p:sp>
+        <p:nvSpPr>
+          <p:cNvPr id="120" name="TextBox 119"/>
+          <p:cNvSpPr txBox="1"/>
+          <p:nvPr/>
+        </p:nvSpPr>
+        <p:spPr>
+          <a:xfrm>
+            <a:off x="1005840" y="6428232"/>
+            <a:ext cx="1600200" cy="182880"/>
+          </a:xfrm>
+          <a:prstGeom prst="rect">
+            <a:avLst/>
+          </a:prstGeom>
+          <a:noFill/>
+        </p:spPr>
+        <p:txBody>
+          <a:bodyPr wrap="none">
+            <a:spAutoFit/>
+          </a:bodyPr>
+          <a:lstStyle/>
+          <a:p>
+            <a:r>
+              <a:rPr sz="819" b="1">
+                <a:solidFill>
+                  <a:srgbClr val="EDE8DF"/>
+                </a:solidFill>
+                <a:latin typeface="Helvetica Neue"/>
+              </a:rPr>
+              <a:t>KALSHI KNOWS</a:t>
+            </a:r>
+          </a:p>
+        </p:txBody>
+      </p:sp>
+      <p:sp>
+        <p:nvSpPr>
+          <p:cNvPr id="121" name="TextBox 120"/>
+          <p:cNvSpPr txBox="1"/>
+          <p:nvPr/>
+        </p:nvSpPr>
+        <p:spPr>
+          <a:xfrm>
+            <a:off x="11503152" y="6428232"/>
+            <a:ext cx="274320" cy="201168"/>
+          </a:xfrm>
+          <a:prstGeom prst="rect">
+            <a:avLst/>
+          </a:prstGeom>
+          <a:noFill/>
+        </p:spPr>
+        <p:txBody>
+          <a:bodyPr wrap="none">
+            <a:spAutoFit/>
+          </a:bodyPr>
+          <a:lstStyle/>
+          <a:p>
+            <a:r>
+              <a:rPr sz="850">
+                <a:solidFill>
+                  <a:srgbClr val="7A848F"/>
+                </a:solidFill>
+                <a:latin typeface="Helvetica Neue"/>
+              </a:rPr>
+              <a:t>06</a:t>
+            </a:r>
+          </a:p>
+        </p:txBody>
+      </p:sp>
+      <p:pic>
+        <p:nvPicPr>
+          <p:cNvPr id="122" name="Picture 121" descr="image.png"/>
+          <p:cNvPicPr>
+            <a:picLocks noChangeAspect="1"/>
+          </p:cNvPicPr>
+          <p:nvPr/>
+        </p:nvPicPr>
+        <p:blipFill>
+          <a:blip r:embed="rId3"/>
+          <a:stretch>
+            <a:fillRect/>
+          </a:stretch>
+        </p:blipFill>
+        <p:spPr>
+          <a:xfrm>
+            <a:off x="621792" y="6432804"/>
+            <a:ext cx="283464" cy="228600"/>
+          </a:xfrm>
+          <a:prstGeom prst="rect">
+            <a:avLst/>
+          </a:prstGeom>
+        </p:spPr>
+      </p:pic>
     </p:spTree>
   </p:cSld>
   <p:clrMapOvr>
@@ -10956,7 +11140,7 @@
         <p:spPr>
           <a:xfrm>
             <a:off x="676656" y="649224"/>
-            <a:ext cx="10927080" cy="1143000"/>
+            <a:ext cx="10927080" cy="914400"/>
           </a:xfrm>
           <a:prstGeom prst="rect">
             <a:avLst/>
@@ -10982,7 +11166,7 @@
               <a:buNone/>
             </a:pPr>
             <a:r>
-              <a:rPr lang="en-US" sz="2820">
+              <a:rPr lang="en-US" sz="3000" b="1">
                 <a:solidFill>
                   <a:srgbClr val="F2F2EF"/>
                 </a:solidFill>
@@ -11006,7 +11190,7 @@
         <p:spPr>
           <a:xfrm>
             <a:off x="704088" y="1627632"/>
-            <a:ext cx="10808208" cy="320040"/>
+            <a:ext cx="10808208" cy="365760"/>
           </a:xfrm>
           <a:prstGeom prst="rect">
             <a:avLst/>
@@ -11171,8 +11355,8 @@
         </p:nvSpPr>
         <p:spPr>
           <a:xfrm>
-            <a:off x="11320272" y="6423660"/>
-            <a:ext cx="210312" cy="201168"/>
+            <a:off x="11503152" y="6428232"/>
+            <a:ext cx="274320" cy="201168"/>
           </a:xfrm>
           <a:prstGeom prst="rect">
             <a:avLst/>
@@ -11222,7 +11406,7 @@
         <p:spPr>
           <a:xfrm>
             <a:off x="704088" y="6153912"/>
-            <a:ext cx="10826496" cy="164592"/>
+            <a:ext cx="10826496" cy="201168"/>
           </a:xfrm>
           <a:prstGeom prst="rect">
             <a:avLst/>
@@ -11849,7 +12033,7 @@
         <p:spPr>
           <a:xfrm>
             <a:off x="676656" y="649224"/>
-            <a:ext cx="10927080" cy="1143000"/>
+            <a:ext cx="10927080" cy="914400"/>
           </a:xfrm>
           <a:prstGeom prst="rect">
             <a:avLst/>
@@ -11875,7 +12059,7 @@
               <a:buNone/>
             </a:pPr>
             <a:r>
-              <a:rPr lang="en-US" sz="3100">
+              <a:rPr lang="en-US" sz="3000" b="1">
                 <a:solidFill>
                   <a:srgbClr val="F2F2EF"/>
                 </a:solidFill>
@@ -11899,7 +12083,7 @@
         <p:spPr>
           <a:xfrm>
             <a:off x="704088" y="1627632"/>
-            <a:ext cx="10808208" cy="320040"/>
+            <a:ext cx="10808208" cy="365760"/>
           </a:xfrm>
           <a:prstGeom prst="rect">
             <a:avLst/>
@@ -12064,8 +12248,8 @@
         </p:nvSpPr>
         <p:spPr>
           <a:xfrm>
-            <a:off x="11320272" y="6423660"/>
-            <a:ext cx="210312" cy="201168"/>
+            <a:off x="11503152" y="6428232"/>
+            <a:ext cx="274320" cy="201168"/>
           </a:xfrm>
           <a:prstGeom prst="rect">
             <a:avLst/>
@@ -12115,7 +12299,7 @@
         <p:spPr>
           <a:xfrm>
             <a:off x="704088" y="6153912"/>
-            <a:ext cx="10826496" cy="164592"/>
+            <a:ext cx="10826496" cy="201168"/>
           </a:xfrm>
           <a:prstGeom prst="rect">
             <a:avLst/>
@@ -14110,7 +14294,7 @@
         <p:spPr>
           <a:xfrm>
             <a:off x="676656" y="649224"/>
-            <a:ext cx="10927080" cy="1143000"/>
+            <a:ext cx="10927080" cy="914400"/>
           </a:xfrm>
           <a:prstGeom prst="rect">
             <a:avLst/>
@@ -14136,7 +14320,7 @@
               <a:buNone/>
             </a:pPr>
             <a:r>
-              <a:rPr lang="en-US" sz="2820">
+              <a:rPr lang="en-US" sz="3000" b="1">
                 <a:solidFill>
                   <a:srgbClr val="F2F2EF"/>
                 </a:solidFill>
@@ -14160,7 +14344,7 @@
         <p:spPr>
           <a:xfrm>
             <a:off x="704088" y="1627632"/>
-            <a:ext cx="10808208" cy="320040"/>
+            <a:ext cx="10808208" cy="365760"/>
           </a:xfrm>
           <a:prstGeom prst="rect">
             <a:avLst/>
@@ -14325,8 +14509,8 @@
         </p:nvSpPr>
         <p:spPr>
           <a:xfrm>
-            <a:off x="11320272" y="6423660"/>
-            <a:ext cx="210312" cy="201168"/>
+            <a:off x="11503152" y="6428232"/>
+            <a:ext cx="274320" cy="201168"/>
           </a:xfrm>
           <a:prstGeom prst="rect">
             <a:avLst/>
@@ -14376,7 +14560,7 @@
         <p:spPr>
           <a:xfrm>
             <a:off x="704088" y="6153912"/>
-            <a:ext cx="10826496" cy="164592"/>
+            <a:ext cx="10826496" cy="201168"/>
           </a:xfrm>
           <a:prstGeom prst="rect">
             <a:avLst/>

</xml_diff>